<commit_message>
Rebuild slide with native editable shapes and text
Co-Authored-By: Claude Sonnet 5.5 <noreply@anthropic.com>
Claude-Session: https://claude.ai/code/session_01MxdMxhi7qZAPC9aBAhtpWC
</commit_message>
<xml_diff>
--- a/kyoiku-jisshu/共育実習_共創モデル.pptx
+++ b/kyoiku-jisshu/共育実習_共創モデル.pptx
@@ -3508,20 +3508,12 @@
         <p:nvPr/>
       </p:nvGrpSpPr>
       <p:grpSpPr/>
-      <p:pic>
-        <p:nvPicPr>
-          <p:cNvPr id="2" name="Picture 1" descr="co-creation-model@2x.png"/>
-          <p:cNvPicPr>
-            <a:picLocks noChangeAspect="1"/>
-          </p:cNvPicPr>
+      <p:sp>
+        <p:nvSpPr>
+          <p:cNvPr id="2" name="背景"/>
+          <p:cNvSpPr/>
           <p:nvPr/>
-        </p:nvPicPr>
-        <p:blipFill>
-          <a:blip r:embed="rId2"/>
-          <a:stretch>
-            <a:fillRect/>
-          </a:stretch>
-        </p:blipFill>
+        </p:nvSpPr>
         <p:spPr>
           <a:xfrm>
             <a:off x="0" y="0"/>
@@ -3530,8 +3522,4236 @@
           <a:prstGeom prst="rect">
             <a:avLst/>
           </a:prstGeom>
-        </p:spPr>
-      </p:pic>
+          <a:solidFill>
+            <a:srgbClr val="E4F5E8"/>
+          </a:solidFill>
+          <a:ln>
+            <a:noFill/>
+          </a:ln>
+          <a:effectLst/>
+        </p:spPr>
+        <p:style>
+          <a:lnRef idx="1">
+            <a:schemeClr val="accent1"/>
+          </a:lnRef>
+          <a:fillRef idx="3">
+            <a:schemeClr val="accent1"/>
+          </a:fillRef>
+          <a:effectRef idx="0">
+            <a:schemeClr val="accent1"/>
+          </a:effectRef>
+          <a:fontRef idx="minor">
+            <a:schemeClr val="lt1"/>
+          </a:fontRef>
+        </p:style>
+        <p:txBody>
+          <a:bodyPr rtlCol="0" anchor="ctr"/>
+          <a:lstStyle/>
+          <a:p>
+            <a:pPr algn="ctr"/>
+          </a:p>
+        </p:txBody>
+      </p:sp>
+      <p:sp>
+        <p:nvSpPr>
+          <p:cNvPr id="3" name="ヘッダー帯"/>
+          <p:cNvSpPr/>
+          <p:nvPr/>
+        </p:nvSpPr>
+        <p:spPr>
+          <a:xfrm>
+            <a:off x="0" y="0"/>
+            <a:ext cx="12192000" cy="1124506"/>
+          </a:xfrm>
+          <a:custGeom>
+            <a:avLst/>
+            <a:gdLst/>
+            <a:ahLst/>
+            <a:cxnLst/>
+            <a:rect l="l" t="t" r="r" b="b"/>
+            <a:pathLst>
+              <a:path w="12192000" h="1124506">
+                <a:moveTo>
+                  <a:pt x="0" y="0"/>
+                </a:moveTo>
+                <a:lnTo>
+                  <a:pt x="12192000" y="0"/>
+                </a:lnTo>
+                <a:lnTo>
+                  <a:pt x="12192000" y="930256"/>
+                </a:lnTo>
+                <a:lnTo>
+                  <a:pt x="12192000" y="930256"/>
+                </a:lnTo>
+                <a:lnTo>
+                  <a:pt x="12141200" y="926860"/>
+                </a:lnTo>
+                <a:lnTo>
+                  <a:pt x="12090400" y="923467"/>
+                </a:lnTo>
+                <a:lnTo>
+                  <a:pt x="12039600" y="920078"/>
+                </a:lnTo>
+                <a:lnTo>
+                  <a:pt x="11988799" y="916698"/>
+                </a:lnTo>
+                <a:lnTo>
+                  <a:pt x="11938000" y="913327"/>
+                </a:lnTo>
+                <a:lnTo>
+                  <a:pt x="11887200" y="909969"/>
+                </a:lnTo>
+                <a:lnTo>
+                  <a:pt x="11836400" y="906626"/>
+                </a:lnTo>
+                <a:lnTo>
+                  <a:pt x="11785600" y="903301"/>
+                </a:lnTo>
+                <a:lnTo>
+                  <a:pt x="11734800" y="899995"/>
+                </a:lnTo>
+                <a:lnTo>
+                  <a:pt x="11684000" y="896713"/>
+                </a:lnTo>
+                <a:lnTo>
+                  <a:pt x="11633200" y="893455"/>
+                </a:lnTo>
+                <a:lnTo>
+                  <a:pt x="11582400" y="890225"/>
+                </a:lnTo>
+                <a:lnTo>
+                  <a:pt x="11531599" y="887024"/>
+                </a:lnTo>
+                <a:lnTo>
+                  <a:pt x="11480800" y="883856"/>
+                </a:lnTo>
+                <a:lnTo>
+                  <a:pt x="11430000" y="880722"/>
+                </a:lnTo>
+                <a:lnTo>
+                  <a:pt x="11379200" y="877626"/>
+                </a:lnTo>
+                <a:lnTo>
+                  <a:pt x="11328400" y="874568"/>
+                </a:lnTo>
+                <a:lnTo>
+                  <a:pt x="11277600" y="871553"/>
+                </a:lnTo>
+                <a:lnTo>
+                  <a:pt x="11226800" y="868581"/>
+                </a:lnTo>
+                <a:lnTo>
+                  <a:pt x="11176000" y="865655"/>
+                </a:lnTo>
+                <a:lnTo>
+                  <a:pt x="11125200" y="862778"/>
+                </a:lnTo>
+                <a:lnTo>
+                  <a:pt x="11074400" y="859950"/>
+                </a:lnTo>
+                <a:lnTo>
+                  <a:pt x="11023600" y="857176"/>
+                </a:lnTo>
+                <a:lnTo>
+                  <a:pt x="10972800" y="854456"/>
+                </a:lnTo>
+                <a:lnTo>
+                  <a:pt x="10922000" y="851793"/>
+                </a:lnTo>
+                <a:lnTo>
+                  <a:pt x="10871200" y="849189"/>
+                </a:lnTo>
+                <a:lnTo>
+                  <a:pt x="10820400" y="846646"/>
+                </a:lnTo>
+                <a:lnTo>
+                  <a:pt x="10769599" y="844166"/>
+                </a:lnTo>
+                <a:lnTo>
+                  <a:pt x="10718800" y="841750"/>
+                </a:lnTo>
+                <a:lnTo>
+                  <a:pt x="10668000" y="839400"/>
+                </a:lnTo>
+                <a:lnTo>
+                  <a:pt x="10617200" y="837119"/>
+                </a:lnTo>
+                <a:lnTo>
+                  <a:pt x="10566400" y="834908"/>
+                </a:lnTo>
+                <a:lnTo>
+                  <a:pt x="10515600" y="832769"/>
+                </a:lnTo>
+                <a:lnTo>
+                  <a:pt x="10464800" y="830703"/>
+                </a:lnTo>
+                <a:lnTo>
+                  <a:pt x="10414000" y="828712"/>
+                </a:lnTo>
+                <a:lnTo>
+                  <a:pt x="10363200" y="826798"/>
+                </a:lnTo>
+                <a:lnTo>
+                  <a:pt x="10312400" y="824962"/>
+                </a:lnTo>
+                <a:lnTo>
+                  <a:pt x="10261600" y="823206"/>
+                </a:lnTo>
+                <a:lnTo>
+                  <a:pt x="10210800" y="821530"/>
+                </a:lnTo>
+                <a:lnTo>
+                  <a:pt x="10160000" y="819937"/>
+                </a:lnTo>
+                <a:lnTo>
+                  <a:pt x="10109200" y="818428"/>
+                </a:lnTo>
+                <a:lnTo>
+                  <a:pt x="10058400" y="817004"/>
+                </a:lnTo>
+                <a:lnTo>
+                  <a:pt x="10007599" y="815665"/>
+                </a:lnTo>
+                <a:lnTo>
+                  <a:pt x="9956800" y="814414"/>
+                </a:lnTo>
+                <a:lnTo>
+                  <a:pt x="9906000" y="813251"/>
+                </a:lnTo>
+                <a:lnTo>
+                  <a:pt x="9855200" y="812177"/>
+                </a:lnTo>
+                <a:lnTo>
+                  <a:pt x="9804400" y="811194"/>
+                </a:lnTo>
+                <a:lnTo>
+                  <a:pt x="9753600" y="810301"/>
+                </a:lnTo>
+                <a:lnTo>
+                  <a:pt x="9702800" y="809501"/>
+                </a:lnTo>
+                <a:lnTo>
+                  <a:pt x="9652000" y="808793"/>
+                </a:lnTo>
+                <a:lnTo>
+                  <a:pt x="9601200" y="808178"/>
+                </a:lnTo>
+                <a:lnTo>
+                  <a:pt x="9550400" y="807658"/>
+                </a:lnTo>
+                <a:lnTo>
+                  <a:pt x="9499600" y="807231"/>
+                </a:lnTo>
+                <a:lnTo>
+                  <a:pt x="9448800" y="806900"/>
+                </a:lnTo>
+                <a:lnTo>
+                  <a:pt x="9398000" y="806664"/>
+                </a:lnTo>
+                <a:lnTo>
+                  <a:pt x="9347200" y="806524"/>
+                </a:lnTo>
+                <a:lnTo>
+                  <a:pt x="9296400" y="806480"/>
+                </a:lnTo>
+                <a:lnTo>
+                  <a:pt x="9245599" y="806533"/>
+                </a:lnTo>
+                <a:lnTo>
+                  <a:pt x="9194800" y="806681"/>
+                </a:lnTo>
+                <a:lnTo>
+                  <a:pt x="9144000" y="806927"/>
+                </a:lnTo>
+                <a:lnTo>
+                  <a:pt x="9093200" y="807269"/>
+                </a:lnTo>
+                <a:lnTo>
+                  <a:pt x="9042400" y="807707"/>
+                </a:lnTo>
+                <a:lnTo>
+                  <a:pt x="8991600" y="808242"/>
+                </a:lnTo>
+                <a:lnTo>
+                  <a:pt x="8940800" y="808873"/>
+                </a:lnTo>
+                <a:lnTo>
+                  <a:pt x="8890000" y="809601"/>
+                </a:lnTo>
+                <a:lnTo>
+                  <a:pt x="8839200" y="810424"/>
+                </a:lnTo>
+                <a:lnTo>
+                  <a:pt x="8788400" y="811342"/>
+                </a:lnTo>
+                <a:lnTo>
+                  <a:pt x="8737600" y="812356"/>
+                </a:lnTo>
+                <a:lnTo>
+                  <a:pt x="8686800" y="813464"/>
+                </a:lnTo>
+                <a:lnTo>
+                  <a:pt x="8635999" y="814666"/>
+                </a:lnTo>
+                <a:lnTo>
+                  <a:pt x="8585200" y="815961"/>
+                </a:lnTo>
+                <a:lnTo>
+                  <a:pt x="8534400" y="817349"/>
+                </a:lnTo>
+                <a:lnTo>
+                  <a:pt x="8483599" y="818829"/>
+                </a:lnTo>
+                <a:lnTo>
+                  <a:pt x="8432800" y="820399"/>
+                </a:lnTo>
+                <a:lnTo>
+                  <a:pt x="8382000" y="822060"/>
+                </a:lnTo>
+                <a:lnTo>
+                  <a:pt x="8331200" y="823811"/>
+                </a:lnTo>
+                <a:lnTo>
+                  <a:pt x="8280400" y="825649"/>
+                </a:lnTo>
+                <a:lnTo>
+                  <a:pt x="8229600" y="827575"/>
+                </a:lnTo>
+                <a:lnTo>
+                  <a:pt x="8178800" y="829586"/>
+                </a:lnTo>
+                <a:lnTo>
+                  <a:pt x="8128000" y="831683"/>
+                </a:lnTo>
+                <a:lnTo>
+                  <a:pt x="8077200" y="833863"/>
+                </a:lnTo>
+                <a:lnTo>
+                  <a:pt x="8026400" y="836126"/>
+                </a:lnTo>
+                <a:lnTo>
+                  <a:pt x="7975599" y="838469"/>
+                </a:lnTo>
+                <a:lnTo>
+                  <a:pt x="7924800" y="840893"/>
+                </a:lnTo>
+                <a:lnTo>
+                  <a:pt x="7873999" y="843394"/>
+                </a:lnTo>
+                <a:lnTo>
+                  <a:pt x="7823199" y="845972"/>
+                </a:lnTo>
+                <a:lnTo>
+                  <a:pt x="7772400" y="848625"/>
+                </a:lnTo>
+                <a:lnTo>
+                  <a:pt x="7721599" y="851352"/>
+                </a:lnTo>
+                <a:lnTo>
+                  <a:pt x="7670799" y="854150"/>
+                </a:lnTo>
+                <a:lnTo>
+                  <a:pt x="7620000" y="857019"/>
+                </a:lnTo>
+                <a:lnTo>
+                  <a:pt x="7569200" y="859955"/>
+                </a:lnTo>
+                <a:lnTo>
+                  <a:pt x="7518400" y="862959"/>
+                </a:lnTo>
+                <a:lnTo>
+                  <a:pt x="7467600" y="866026"/>
+                </a:lnTo>
+                <a:lnTo>
+                  <a:pt x="7416800" y="869157"/>
+                </a:lnTo>
+                <a:lnTo>
+                  <a:pt x="7366000" y="872348"/>
+                </a:lnTo>
+                <a:lnTo>
+                  <a:pt x="7315200" y="875599"/>
+                </a:lnTo>
+                <a:lnTo>
+                  <a:pt x="7264400" y="878906"/>
+                </a:lnTo>
+                <a:lnTo>
+                  <a:pt x="7213600" y="882267"/>
+                </a:lnTo>
+                <a:lnTo>
+                  <a:pt x="7162800" y="885682"/>
+                </a:lnTo>
+                <a:lnTo>
+                  <a:pt x="7111999" y="889146"/>
+                </a:lnTo>
+                <a:lnTo>
+                  <a:pt x="7061199" y="892659"/>
+                </a:lnTo>
+                <a:lnTo>
+                  <a:pt x="7010399" y="896219"/>
+                </a:lnTo>
+                <a:lnTo>
+                  <a:pt x="6959600" y="899822"/>
+                </a:lnTo>
+                <a:lnTo>
+                  <a:pt x="6908799" y="903466"/>
+                </a:lnTo>
+                <a:lnTo>
+                  <a:pt x="6858000" y="907150"/>
+                </a:lnTo>
+                <a:lnTo>
+                  <a:pt x="6807200" y="910871"/>
+                </a:lnTo>
+                <a:lnTo>
+                  <a:pt x="6756400" y="914626"/>
+                </a:lnTo>
+                <a:lnTo>
+                  <a:pt x="6705600" y="918414"/>
+                </a:lnTo>
+                <a:lnTo>
+                  <a:pt x="6654800" y="922232"/>
+                </a:lnTo>
+                <a:lnTo>
+                  <a:pt x="6604000" y="926077"/>
+                </a:lnTo>
+                <a:lnTo>
+                  <a:pt x="6553200" y="929947"/>
+                </a:lnTo>
+                <a:lnTo>
+                  <a:pt x="6502400" y="933839"/>
+                </a:lnTo>
+                <a:lnTo>
+                  <a:pt x="6451600" y="937752"/>
+                </a:lnTo>
+                <a:lnTo>
+                  <a:pt x="6400800" y="941682"/>
+                </a:lnTo>
+                <a:lnTo>
+                  <a:pt x="6349999" y="945628"/>
+                </a:lnTo>
+                <a:lnTo>
+                  <a:pt x="6299199" y="949585"/>
+                </a:lnTo>
+                <a:lnTo>
+                  <a:pt x="6248399" y="953554"/>
+                </a:lnTo>
+                <a:lnTo>
+                  <a:pt x="6197600" y="957529"/>
+                </a:lnTo>
+                <a:lnTo>
+                  <a:pt x="6146799" y="961510"/>
+                </a:lnTo>
+                <a:lnTo>
+                  <a:pt x="6096000" y="965493"/>
+                </a:lnTo>
+                <a:lnTo>
+                  <a:pt x="6045200" y="969476"/>
+                </a:lnTo>
+                <a:lnTo>
+                  <a:pt x="5994400" y="973457"/>
+                </a:lnTo>
+                <a:lnTo>
+                  <a:pt x="5943600" y="977433"/>
+                </a:lnTo>
+                <a:lnTo>
+                  <a:pt x="5892800" y="981401"/>
+                </a:lnTo>
+                <a:lnTo>
+                  <a:pt x="5841999" y="985359"/>
+                </a:lnTo>
+                <a:lnTo>
+                  <a:pt x="5791200" y="989304"/>
+                </a:lnTo>
+                <a:lnTo>
+                  <a:pt x="5740400" y="993234"/>
+                </a:lnTo>
+                <a:lnTo>
+                  <a:pt x="5689600" y="997147"/>
+                </a:lnTo>
+                <a:lnTo>
+                  <a:pt x="5638800" y="1001040"/>
+                </a:lnTo>
+                <a:lnTo>
+                  <a:pt x="5588000" y="1004910"/>
+                </a:lnTo>
+                <a:lnTo>
+                  <a:pt x="5537200" y="1008755"/>
+                </a:lnTo>
+                <a:lnTo>
+                  <a:pt x="5486399" y="1012572"/>
+                </a:lnTo>
+                <a:lnTo>
+                  <a:pt x="5435600" y="1016360"/>
+                </a:lnTo>
+                <a:lnTo>
+                  <a:pt x="5384799" y="1020115"/>
+                </a:lnTo>
+                <a:lnTo>
+                  <a:pt x="5334000" y="1023836"/>
+                </a:lnTo>
+                <a:lnTo>
+                  <a:pt x="5283200" y="1027520"/>
+                </a:lnTo>
+                <a:lnTo>
+                  <a:pt x="5232400" y="1031165"/>
+                </a:lnTo>
+                <a:lnTo>
+                  <a:pt x="5181600" y="1034768"/>
+                </a:lnTo>
+                <a:lnTo>
+                  <a:pt x="5130800" y="1038327"/>
+                </a:lnTo>
+                <a:lnTo>
+                  <a:pt x="5079999" y="1041840"/>
+                </a:lnTo>
+                <a:lnTo>
+                  <a:pt x="5029200" y="1045305"/>
+                </a:lnTo>
+                <a:lnTo>
+                  <a:pt x="4978400" y="1048719"/>
+                </a:lnTo>
+                <a:lnTo>
+                  <a:pt x="4927600" y="1052081"/>
+                </a:lnTo>
+                <a:lnTo>
+                  <a:pt x="4876800" y="1055388"/>
+                </a:lnTo>
+                <a:lnTo>
+                  <a:pt x="4826000" y="1058638"/>
+                </a:lnTo>
+                <a:lnTo>
+                  <a:pt x="4775200" y="1061829"/>
+                </a:lnTo>
+                <a:lnTo>
+                  <a:pt x="4724399" y="1064960"/>
+                </a:lnTo>
+                <a:lnTo>
+                  <a:pt x="4673600" y="1068028"/>
+                </a:lnTo>
+                <a:lnTo>
+                  <a:pt x="4622799" y="1071031"/>
+                </a:lnTo>
+                <a:lnTo>
+                  <a:pt x="4572000" y="1073968"/>
+                </a:lnTo>
+                <a:lnTo>
+                  <a:pt x="4521200" y="1076836"/>
+                </a:lnTo>
+                <a:lnTo>
+                  <a:pt x="4470400" y="1079634"/>
+                </a:lnTo>
+                <a:lnTo>
+                  <a:pt x="4419600" y="1082361"/>
+                </a:lnTo>
+                <a:lnTo>
+                  <a:pt x="4368800" y="1085014"/>
+                </a:lnTo>
+                <a:lnTo>
+                  <a:pt x="4317999" y="1087592"/>
+                </a:lnTo>
+                <a:lnTo>
+                  <a:pt x="4267200" y="1090094"/>
+                </a:lnTo>
+                <a:lnTo>
+                  <a:pt x="4216400" y="1092517"/>
+                </a:lnTo>
+                <a:lnTo>
+                  <a:pt x="4165600" y="1094860"/>
+                </a:lnTo>
+                <a:lnTo>
+                  <a:pt x="4114800" y="1097123"/>
+                </a:lnTo>
+                <a:lnTo>
+                  <a:pt x="4064000" y="1099303"/>
+                </a:lnTo>
+                <a:lnTo>
+                  <a:pt x="4013200" y="1101400"/>
+                </a:lnTo>
+                <a:lnTo>
+                  <a:pt x="3962399" y="1103412"/>
+                </a:lnTo>
+                <a:lnTo>
+                  <a:pt x="3911599" y="1105337"/>
+                </a:lnTo>
+                <a:lnTo>
+                  <a:pt x="3860799" y="1107176"/>
+                </a:lnTo>
+                <a:lnTo>
+                  <a:pt x="3810000" y="1108926"/>
+                </a:lnTo>
+                <a:lnTo>
+                  <a:pt x="3759200" y="1110587"/>
+                </a:lnTo>
+                <a:lnTo>
+                  <a:pt x="3708400" y="1112158"/>
+                </a:lnTo>
+                <a:lnTo>
+                  <a:pt x="3657600" y="1113637"/>
+                </a:lnTo>
+                <a:lnTo>
+                  <a:pt x="3606799" y="1115025"/>
+                </a:lnTo>
+                <a:lnTo>
+                  <a:pt x="3555999" y="1116321"/>
+                </a:lnTo>
+                <a:lnTo>
+                  <a:pt x="3505199" y="1117522"/>
+                </a:lnTo>
+                <a:lnTo>
+                  <a:pt x="3454399" y="1118630"/>
+                </a:lnTo>
+                <a:lnTo>
+                  <a:pt x="3403600" y="1119644"/>
+                </a:lnTo>
+                <a:lnTo>
+                  <a:pt x="3352800" y="1120562"/>
+                </a:lnTo>
+                <a:lnTo>
+                  <a:pt x="3302000" y="1121386"/>
+                </a:lnTo>
+                <a:lnTo>
+                  <a:pt x="3251200" y="1122113"/>
+                </a:lnTo>
+                <a:lnTo>
+                  <a:pt x="3200399" y="1122744"/>
+                </a:lnTo>
+                <a:lnTo>
+                  <a:pt x="3149599" y="1123279"/>
+                </a:lnTo>
+                <a:lnTo>
+                  <a:pt x="3098800" y="1123718"/>
+                </a:lnTo>
+                <a:lnTo>
+                  <a:pt x="3048000" y="1124060"/>
+                </a:lnTo>
+                <a:lnTo>
+                  <a:pt x="2997200" y="1124305"/>
+                </a:lnTo>
+                <a:lnTo>
+                  <a:pt x="2946400" y="1124454"/>
+                </a:lnTo>
+                <a:lnTo>
+                  <a:pt x="2895600" y="1124506"/>
+                </a:lnTo>
+                <a:lnTo>
+                  <a:pt x="2844799" y="1124462"/>
+                </a:lnTo>
+                <a:lnTo>
+                  <a:pt x="2793999" y="1124322"/>
+                </a:lnTo>
+                <a:lnTo>
+                  <a:pt x="2743199" y="1124086"/>
+                </a:lnTo>
+                <a:lnTo>
+                  <a:pt x="2692399" y="1123755"/>
+                </a:lnTo>
+                <a:lnTo>
+                  <a:pt x="2641600" y="1123329"/>
+                </a:lnTo>
+                <a:lnTo>
+                  <a:pt x="2590800" y="1122808"/>
+                </a:lnTo>
+                <a:lnTo>
+                  <a:pt x="2540000" y="1122193"/>
+                </a:lnTo>
+                <a:lnTo>
+                  <a:pt x="2489200" y="1121485"/>
+                </a:lnTo>
+                <a:lnTo>
+                  <a:pt x="2438399" y="1120685"/>
+                </a:lnTo>
+                <a:lnTo>
+                  <a:pt x="2387599" y="1119792"/>
+                </a:lnTo>
+                <a:lnTo>
+                  <a:pt x="2336800" y="1118809"/>
+                </a:lnTo>
+                <a:lnTo>
+                  <a:pt x="2286000" y="1117735"/>
+                </a:lnTo>
+                <a:lnTo>
+                  <a:pt x="2235200" y="1116572"/>
+                </a:lnTo>
+                <a:lnTo>
+                  <a:pt x="2184400" y="1115321"/>
+                </a:lnTo>
+                <a:lnTo>
+                  <a:pt x="2133600" y="1113983"/>
+                </a:lnTo>
+                <a:lnTo>
+                  <a:pt x="2082799" y="1112558"/>
+                </a:lnTo>
+                <a:lnTo>
+                  <a:pt x="2031999" y="1111049"/>
+                </a:lnTo>
+                <a:lnTo>
+                  <a:pt x="1981199" y="1109456"/>
+                </a:lnTo>
+                <a:lnTo>
+                  <a:pt x="1930399" y="1107781"/>
+                </a:lnTo>
+                <a:lnTo>
+                  <a:pt x="1879600" y="1106024"/>
+                </a:lnTo>
+                <a:lnTo>
+                  <a:pt x="1828800" y="1104188"/>
+                </a:lnTo>
+                <a:lnTo>
+                  <a:pt x="1778000" y="1102274"/>
+                </a:lnTo>
+                <a:lnTo>
+                  <a:pt x="1727200" y="1100283"/>
+                </a:lnTo>
+                <a:lnTo>
+                  <a:pt x="1676399" y="1098218"/>
+                </a:lnTo>
+                <a:lnTo>
+                  <a:pt x="1625599" y="1096078"/>
+                </a:lnTo>
+                <a:lnTo>
+                  <a:pt x="1574799" y="1093867"/>
+                </a:lnTo>
+                <a:lnTo>
+                  <a:pt x="1524000" y="1091586"/>
+                </a:lnTo>
+                <a:lnTo>
+                  <a:pt x="1473200" y="1089237"/>
+                </a:lnTo>
+                <a:lnTo>
+                  <a:pt x="1422400" y="1086821"/>
+                </a:lnTo>
+                <a:lnTo>
+                  <a:pt x="1371600" y="1084340"/>
+                </a:lnTo>
+                <a:lnTo>
+                  <a:pt x="1320799" y="1081797"/>
+                </a:lnTo>
+                <a:lnTo>
+                  <a:pt x="1269999" y="1079193"/>
+                </a:lnTo>
+                <a:lnTo>
+                  <a:pt x="1219199" y="1076530"/>
+                </a:lnTo>
+                <a:lnTo>
+                  <a:pt x="1168400" y="1073810"/>
+                </a:lnTo>
+                <a:lnTo>
+                  <a:pt x="1117600" y="1071036"/>
+                </a:lnTo>
+                <a:lnTo>
+                  <a:pt x="1066800" y="1068209"/>
+                </a:lnTo>
+                <a:lnTo>
+                  <a:pt x="1016000" y="1065331"/>
+                </a:lnTo>
+                <a:lnTo>
+                  <a:pt x="965200" y="1062406"/>
+                </a:lnTo>
+                <a:lnTo>
+                  <a:pt x="914399" y="1059434"/>
+                </a:lnTo>
+                <a:lnTo>
+                  <a:pt x="863599" y="1056418"/>
+                </a:lnTo>
+                <a:lnTo>
+                  <a:pt x="812799" y="1053361"/>
+                </a:lnTo>
+                <a:lnTo>
+                  <a:pt x="762000" y="1050264"/>
+                </a:lnTo>
+                <a:lnTo>
+                  <a:pt x="711200" y="1047130"/>
+                </a:lnTo>
+                <a:lnTo>
+                  <a:pt x="660400" y="1043962"/>
+                </a:lnTo>
+                <a:lnTo>
+                  <a:pt x="609600" y="1040762"/>
+                </a:lnTo>
+                <a:lnTo>
+                  <a:pt x="558799" y="1037531"/>
+                </a:lnTo>
+                <a:lnTo>
+                  <a:pt x="507999" y="1034274"/>
+                </a:lnTo>
+                <a:lnTo>
+                  <a:pt x="457199" y="1030991"/>
+                </a:lnTo>
+                <a:lnTo>
+                  <a:pt x="406399" y="1027686"/>
+                </a:lnTo>
+                <a:lnTo>
+                  <a:pt x="355600" y="1024360"/>
+                </a:lnTo>
+                <a:lnTo>
+                  <a:pt x="304800" y="1021017"/>
+                </a:lnTo>
+                <a:lnTo>
+                  <a:pt x="254000" y="1017659"/>
+                </a:lnTo>
+                <a:lnTo>
+                  <a:pt x="203200" y="1014289"/>
+                </a:lnTo>
+                <a:lnTo>
+                  <a:pt x="152399" y="1010908"/>
+                </a:lnTo>
+                <a:lnTo>
+                  <a:pt x="101599" y="1007519"/>
+                </a:lnTo>
+                <a:lnTo>
+                  <a:pt x="50799" y="1004126"/>
+                </a:lnTo>
+                <a:lnTo>
+                  <a:pt x="0" y="1000730"/>
+                </a:lnTo>
+                <a:close/>
+              </a:path>
+            </a:pathLst>
+          </a:custGeom>
+          <a:solidFill>
+            <a:srgbClr val="54C5AF"/>
+          </a:solidFill>
+          <a:ln>
+            <a:noFill/>
+          </a:ln>
+          <a:effectLst/>
+        </p:spPr>
+        <p:style>
+          <a:lnRef idx="1">
+            <a:schemeClr val="accent1"/>
+          </a:lnRef>
+          <a:fillRef idx="3">
+            <a:schemeClr val="accent1"/>
+          </a:fillRef>
+          <a:effectRef idx="0">
+            <a:schemeClr val="accent1"/>
+          </a:effectRef>
+          <a:fontRef idx="minor">
+            <a:schemeClr val="lt1"/>
+          </a:fontRef>
+        </p:style>
+        <p:txBody>
+          <a:bodyPr rtlCol="0" anchor="ctr"/>
+          <a:lstStyle/>
+          <a:p>
+            <a:pPr algn="ctr"/>
+          </a:p>
+        </p:txBody>
+      </p:sp>
+      <p:sp>
+        <p:nvSpPr>
+          <p:cNvPr id="4" name="小見出し"/>
+          <p:cNvSpPr txBox="1"/>
+          <p:nvPr/>
+        </p:nvSpPr>
+        <p:spPr>
+          <a:xfrm>
+            <a:off x="451033" y="211421"/>
+            <a:ext cx="4933179" cy="211421"/>
+          </a:xfrm>
+          <a:prstGeom prst="rect">
+            <a:avLst/>
+          </a:prstGeom>
+          <a:noFill/>
+        </p:spPr>
+        <p:txBody>
+          <a:bodyPr wrap="square" lIns="0" rIns="0" tIns="0" bIns="0" anchor="t">
+            <a:spAutoFit/>
+          </a:bodyPr>
+          <a:lstStyle/>
+          <a:p>
+            <a:pPr algn="l"/>
+            <a:r>
+              <a:rPr sz="1109" b="1" spc="400">
+                <a:solidFill>
+                  <a:srgbClr val="D9F6EE"/>
+                </a:solidFill>
+                <a:latin typeface="游ゴシック"/>
+                <a:ea typeface="游ゴシック"/>
+                <a:cs typeface="游ゴシック"/>
+              </a:rPr>
+              <a:t>施策①　共育実習</a:t>
+            </a:r>
+          </a:p>
+        </p:txBody>
+      </p:sp>
+      <p:sp>
+        <p:nvSpPr>
+          <p:cNvPr id="5" name="タイトル"/>
+          <p:cNvSpPr txBox="1"/>
+          <p:nvPr/>
+        </p:nvSpPr>
+        <p:spPr>
+          <a:xfrm>
+            <a:off x="451033" y="422843"/>
+            <a:ext cx="8456878" cy="493317"/>
+          </a:xfrm>
+          <a:prstGeom prst="rect">
+            <a:avLst/>
+          </a:prstGeom>
+          <a:noFill/>
+        </p:spPr>
+        <p:txBody>
+          <a:bodyPr wrap="square" lIns="0" rIns="0" tIns="0" bIns="0" anchor="t">
+            <a:spAutoFit/>
+          </a:bodyPr>
+          <a:lstStyle/>
+          <a:p>
+            <a:pPr algn="l"/>
+            <a:r>
+              <a:rPr sz="2552" b="1">
+                <a:solidFill>
+                  <a:srgbClr val="FFFFFF"/>
+                </a:solidFill>
+                <a:latin typeface="游ゴシック"/>
+                <a:ea typeface="游ゴシック"/>
+                <a:cs typeface="游ゴシック"/>
+              </a:rPr>
+              <a:t>共育実習の共創モデル</a:t>
+            </a:r>
+          </a:p>
+        </p:txBody>
+      </p:sp>
+      <p:sp>
+        <p:nvSpPr>
+          <p:cNvPr id="6" name="中央円"/>
+          <p:cNvSpPr/>
+          <p:nvPr/>
+        </p:nvSpPr>
+        <p:spPr>
+          <a:xfrm>
+            <a:off x="4841563" y="2424305"/>
+            <a:ext cx="2508873" cy="2508873"/>
+          </a:xfrm>
+          <a:prstGeom prst="ellipse">
+            <a:avLst/>
+          </a:prstGeom>
+          <a:solidFill>
+            <a:srgbClr val="FFFFFF"/>
+          </a:solidFill>
+          <a:ln>
+            <a:noFill/>
+          </a:ln>
+          <a:effectLst>
+            <a:outerShdw blurRad="112758" dist="42284" dir="5400000" algn="t" rotWithShape="0">
+              <a:srgbClr val="2E9E8A">
+                <a:alpha val="16000"/>
+              </a:srgbClr>
+            </a:outerShdw>
+          </a:effectLst>
+        </p:spPr>
+        <p:style>
+          <a:lnRef idx="1">
+            <a:schemeClr val="accent1"/>
+          </a:lnRef>
+          <a:fillRef idx="3">
+            <a:schemeClr val="accent1"/>
+          </a:fillRef>
+          <a:effectRef idx="0">
+            <a:schemeClr val="accent1"/>
+          </a:effectRef>
+          <a:fontRef idx="minor">
+            <a:schemeClr val="lt1"/>
+          </a:fontRef>
+        </p:style>
+        <p:txBody>
+          <a:bodyPr rtlCol="0" anchor="ctr"/>
+          <a:lstStyle/>
+          <a:p>
+            <a:pPr algn="ctr"/>
+          </a:p>
+        </p:txBody>
+      </p:sp>
+      <p:sp>
+        <p:nvSpPr>
+          <p:cNvPr id="7" name="Oval 6"/>
+          <p:cNvSpPr/>
+          <p:nvPr/>
+        </p:nvSpPr>
+        <p:spPr>
+          <a:xfrm>
+            <a:off x="4940226" y="2522968"/>
+            <a:ext cx="2311546" cy="2311546"/>
+          </a:xfrm>
+          <a:prstGeom prst="ellipse">
+            <a:avLst/>
+          </a:prstGeom>
+          <a:noFill/>
+          <a:ln w="15240">
+            <a:solidFill>
+              <a:srgbClr val="CFEEE3"/>
+            </a:solidFill>
+            <a:prstDash val="sysDot"/>
+          </a:ln>
+          <a:effectLst/>
+        </p:spPr>
+        <p:style>
+          <a:lnRef idx="1">
+            <a:schemeClr val="accent1"/>
+          </a:lnRef>
+          <a:fillRef idx="3">
+            <a:schemeClr val="accent1"/>
+          </a:fillRef>
+          <a:effectRef idx="0">
+            <a:schemeClr val="accent1"/>
+          </a:effectRef>
+          <a:fontRef idx="minor">
+            <a:schemeClr val="lt1"/>
+          </a:fontRef>
+        </p:style>
+        <p:txBody>
+          <a:bodyPr rtlCol="0" anchor="ctr"/>
+          <a:lstStyle/>
+          <a:p>
+            <a:pPr algn="ctr"/>
+          </a:p>
+        </p:txBody>
+      </p:sp>
+      <p:sp>
+        <p:nvSpPr>
+          <p:cNvPr id="8" name="中央ミニ見出し"/>
+          <p:cNvSpPr txBox="1"/>
+          <p:nvPr/>
+        </p:nvSpPr>
+        <p:spPr>
+          <a:xfrm>
+            <a:off x="5038890" y="3129045"/>
+            <a:ext cx="2114219" cy="211421"/>
+          </a:xfrm>
+          <a:prstGeom prst="rect">
+            <a:avLst/>
+          </a:prstGeom>
+          <a:noFill/>
+        </p:spPr>
+        <p:txBody>
+          <a:bodyPr wrap="square" lIns="0" rIns="0" tIns="0" bIns="0" anchor="t">
+            <a:spAutoFit/>
+          </a:bodyPr>
+          <a:lstStyle/>
+          <a:p>
+            <a:pPr algn="ctr"/>
+            <a:r>
+              <a:rPr sz="1276" b="1" spc="200">
+                <a:solidFill>
+                  <a:srgbClr val="2E9E8A"/>
+                </a:solidFill>
+                <a:latin typeface="游ゴシック"/>
+                <a:ea typeface="游ゴシック"/>
+                <a:cs typeface="游ゴシック"/>
+              </a:rPr>
+              <a:t>エフビー介護の</a:t>
+            </a:r>
+          </a:p>
+        </p:txBody>
+      </p:sp>
+      <p:sp>
+        <p:nvSpPr>
+          <p:cNvPr id="9" name="中央タイトル"/>
+          <p:cNvSpPr txBox="1"/>
+          <p:nvPr/>
+        </p:nvSpPr>
+        <p:spPr>
+          <a:xfrm>
+            <a:off x="4933179" y="3312277"/>
+            <a:ext cx="2325641" cy="704739"/>
+          </a:xfrm>
+          <a:prstGeom prst="rect">
+            <a:avLst/>
+          </a:prstGeom>
+          <a:noFill/>
+        </p:spPr>
+        <p:txBody>
+          <a:bodyPr wrap="square" lIns="0" rIns="0" tIns="0" bIns="0" anchor="t">
+            <a:spAutoFit/>
+          </a:bodyPr>
+          <a:lstStyle/>
+          <a:p>
+            <a:pPr algn="ctr"/>
+            <a:r>
+              <a:rPr sz="3773" b="1">
+                <a:solidFill>
+                  <a:srgbClr val="26323A"/>
+                </a:solidFill>
+                <a:latin typeface="游ゴシック"/>
+                <a:ea typeface="游ゴシック"/>
+                <a:cs typeface="游ゴシック"/>
+              </a:rPr>
+              <a:t>共育実習</a:t>
+            </a:r>
+          </a:p>
+        </p:txBody>
+      </p:sp>
+      <p:sp>
+        <p:nvSpPr>
+          <p:cNvPr id="10" name="共に育つ帯"/>
+          <p:cNvSpPr/>
+          <p:nvPr/>
+        </p:nvSpPr>
+        <p:spPr>
+          <a:xfrm>
+            <a:off x="5546302" y="4045206"/>
+            <a:ext cx="1099394" cy="267801"/>
+          </a:xfrm>
+          <a:prstGeom prst="roundRect">
+            <a:avLst>
+              <a:gd name="adj" fmla="val 50000"/>
+            </a:avLst>
+          </a:prstGeom>
+          <a:solidFill>
+            <a:srgbClr val="F28C3C"/>
+          </a:solidFill>
+          <a:ln>
+            <a:noFill/>
+          </a:ln>
+          <a:effectLst/>
+        </p:spPr>
+        <p:style>
+          <a:lnRef idx="1">
+            <a:schemeClr val="accent1"/>
+          </a:lnRef>
+          <a:fillRef idx="3">
+            <a:schemeClr val="accent1"/>
+          </a:fillRef>
+          <a:effectRef idx="0">
+            <a:schemeClr val="accent1"/>
+          </a:effectRef>
+          <a:fontRef idx="minor">
+            <a:schemeClr val="lt1"/>
+          </a:fontRef>
+        </p:style>
+        <p:txBody>
+          <a:bodyPr rtlCol="0" anchor="ctr"/>
+          <a:lstStyle/>
+          <a:p>
+            <a:pPr algn="ctr"/>
+          </a:p>
+        </p:txBody>
+      </p:sp>
+      <p:sp>
+        <p:nvSpPr>
+          <p:cNvPr id="11" name="共に育つ"/>
+          <p:cNvSpPr txBox="1"/>
+          <p:nvPr/>
+        </p:nvSpPr>
+        <p:spPr>
+          <a:xfrm>
+            <a:off x="5546302" y="4045206"/>
+            <a:ext cx="1099394" cy="267801"/>
+          </a:xfrm>
+          <a:prstGeom prst="rect">
+            <a:avLst/>
+          </a:prstGeom>
+          <a:noFill/>
+        </p:spPr>
+        <p:txBody>
+          <a:bodyPr wrap="square" lIns="0" rIns="0" tIns="0" bIns="0" anchor="ctr">
+            <a:spAutoFit/>
+          </a:bodyPr>
+          <a:lstStyle/>
+          <a:p>
+            <a:pPr algn="ctr"/>
+            <a:r>
+              <a:rPr sz="1165" b="1" spc="300">
+                <a:solidFill>
+                  <a:srgbClr val="FFFFFF"/>
+                </a:solidFill>
+                <a:latin typeface="游ゴシック"/>
+                <a:ea typeface="游ゴシック"/>
+                <a:cs typeface="游ゴシック"/>
+              </a:rPr>
+              <a:t>共に育つ</a:t>
+            </a:r>
+          </a:p>
+        </p:txBody>
+      </p:sp>
+      <p:sp>
+        <p:nvSpPr>
+          <p:cNvPr id="12" name="環_エフビー介護サービス"/>
+          <p:cNvSpPr/>
+          <p:nvPr/>
+        </p:nvSpPr>
+        <p:spPr>
+          <a:xfrm>
+            <a:off x="4108633" y="1691375"/>
+            <a:ext cx="3974732" cy="3974732"/>
+          </a:xfrm>
+          <a:prstGeom prst="blockArc">
+            <a:avLst>
+              <a:gd name="adj1" fmla="val 16356000"/>
+              <a:gd name="adj2" fmla="val 19644000"/>
+              <a:gd name="adj3" fmla="val 14539"/>
+            </a:avLst>
+          </a:prstGeom>
+          <a:solidFill>
+            <a:srgbClr val="F28C3C"/>
+          </a:solidFill>
+          <a:ln>
+            <a:noFill/>
+          </a:ln>
+          <a:effectLst/>
+        </p:spPr>
+        <p:style>
+          <a:lnRef idx="1">
+            <a:schemeClr val="accent1"/>
+          </a:lnRef>
+          <a:fillRef idx="3">
+            <a:schemeClr val="accent1"/>
+          </a:fillRef>
+          <a:effectRef idx="0">
+            <a:schemeClr val="accent1"/>
+          </a:effectRef>
+          <a:fontRef idx="minor">
+            <a:schemeClr val="lt1"/>
+          </a:fontRef>
+        </p:style>
+        <p:txBody>
+          <a:bodyPr rtlCol="0" anchor="ctr"/>
+          <a:lstStyle/>
+          <a:p>
+            <a:pPr algn="ctr"/>
+          </a:p>
+        </p:txBody>
+      </p:sp>
+      <p:sp>
+        <p:nvSpPr>
+          <p:cNvPr id="13" name="環ラベル_エフビー介護サービス"/>
+          <p:cNvSpPr txBox="1"/>
+          <p:nvPr/>
+        </p:nvSpPr>
+        <p:spPr>
+          <a:xfrm rot="1800000">
+            <a:off x="6416656" y="2081011"/>
+            <a:ext cx="1057109" cy="253706"/>
+          </a:xfrm>
+          <a:prstGeom prst="rect">
+            <a:avLst/>
+          </a:prstGeom>
+          <a:noFill/>
+        </p:spPr>
+        <p:txBody>
+          <a:bodyPr wrap="square" lIns="0" rIns="0" tIns="0" bIns="0" anchor="ctr">
+            <a:spAutoFit/>
+          </a:bodyPr>
+          <a:lstStyle/>
+          <a:p>
+            <a:pPr algn="ctr"/>
+            <a:r>
+              <a:rPr sz="1331" b="1" spc="200">
+                <a:solidFill>
+                  <a:srgbClr val="FFFFFF"/>
+                </a:solidFill>
+                <a:latin typeface="游ゴシック"/>
+                <a:ea typeface="游ゴシック"/>
+                <a:cs typeface="游ゴシック"/>
+              </a:rPr>
+              <a:t>エフビー</a:t>
+            </a:r>
+          </a:p>
+        </p:txBody>
+      </p:sp>
+      <p:sp>
+        <p:nvSpPr>
+          <p:cNvPr id="14" name="環_社員"/>
+          <p:cNvSpPr/>
+          <p:nvPr/>
+        </p:nvSpPr>
+        <p:spPr>
+          <a:xfrm>
+            <a:off x="4108633" y="1691375"/>
+            <a:ext cx="3974732" cy="3974732"/>
+          </a:xfrm>
+          <a:prstGeom prst="blockArc">
+            <a:avLst>
+              <a:gd name="adj1" fmla="val 19956000"/>
+              <a:gd name="adj2" fmla="val 1644000"/>
+              <a:gd name="adj3" fmla="val 14539"/>
+            </a:avLst>
+          </a:prstGeom>
+          <a:solidFill>
+            <a:srgbClr val="F7AB67"/>
+          </a:solidFill>
+          <a:ln>
+            <a:noFill/>
+          </a:ln>
+          <a:effectLst/>
+        </p:spPr>
+        <p:style>
+          <a:lnRef idx="1">
+            <a:schemeClr val="accent1"/>
+          </a:lnRef>
+          <a:fillRef idx="3">
+            <a:schemeClr val="accent1"/>
+          </a:fillRef>
+          <a:effectRef idx="0">
+            <a:schemeClr val="accent1"/>
+          </a:effectRef>
+          <a:fontRef idx="minor">
+            <a:schemeClr val="lt1"/>
+          </a:fontRef>
+        </p:style>
+        <p:txBody>
+          <a:bodyPr rtlCol="0" anchor="ctr"/>
+          <a:lstStyle/>
+          <a:p>
+            <a:pPr algn="ctr"/>
+          </a:p>
+        </p:txBody>
+      </p:sp>
+      <p:sp>
+        <p:nvSpPr>
+          <p:cNvPr id="15" name="環ラベル_社員"/>
+          <p:cNvSpPr txBox="1"/>
+          <p:nvPr/>
+        </p:nvSpPr>
+        <p:spPr>
+          <a:xfrm rot="5400000">
+            <a:off x="7265868" y="3551889"/>
+            <a:ext cx="1057109" cy="253706"/>
+          </a:xfrm>
+          <a:prstGeom prst="rect">
+            <a:avLst/>
+          </a:prstGeom>
+          <a:noFill/>
+        </p:spPr>
+        <p:txBody>
+          <a:bodyPr wrap="square" lIns="0" rIns="0" tIns="0" bIns="0" anchor="ctr">
+            <a:spAutoFit/>
+          </a:bodyPr>
+          <a:lstStyle/>
+          <a:p>
+            <a:pPr algn="ctr"/>
+            <a:r>
+              <a:rPr sz="1498" b="1" spc="200">
+                <a:solidFill>
+                  <a:srgbClr val="FFFFFF"/>
+                </a:solidFill>
+                <a:latin typeface="游ゴシック"/>
+                <a:ea typeface="游ゴシック"/>
+                <a:cs typeface="游ゴシック"/>
+              </a:rPr>
+              <a:t>社員</a:t>
+            </a:r>
+          </a:p>
+        </p:txBody>
+      </p:sp>
+      <p:sp>
+        <p:nvSpPr>
+          <p:cNvPr id="16" name="環_地域"/>
+          <p:cNvSpPr/>
+          <p:nvPr/>
+        </p:nvSpPr>
+        <p:spPr>
+          <a:xfrm>
+            <a:off x="4108633" y="1691375"/>
+            <a:ext cx="3974732" cy="3974732"/>
+          </a:xfrm>
+          <a:prstGeom prst="blockArc">
+            <a:avLst>
+              <a:gd name="adj1" fmla="val 1955999"/>
+              <a:gd name="adj2" fmla="val 5244000"/>
+              <a:gd name="adj3" fmla="val 14539"/>
+            </a:avLst>
+          </a:prstGeom>
+          <a:solidFill>
+            <a:srgbClr val="2E9E8A"/>
+          </a:solidFill>
+          <a:ln>
+            <a:noFill/>
+          </a:ln>
+          <a:effectLst/>
+        </p:spPr>
+        <p:style>
+          <a:lnRef idx="1">
+            <a:schemeClr val="accent1"/>
+          </a:lnRef>
+          <a:fillRef idx="3">
+            <a:schemeClr val="accent1"/>
+          </a:fillRef>
+          <a:effectRef idx="0">
+            <a:schemeClr val="accent1"/>
+          </a:effectRef>
+          <a:fontRef idx="minor">
+            <a:schemeClr val="lt1"/>
+          </a:fontRef>
+        </p:style>
+        <p:txBody>
+          <a:bodyPr rtlCol="0" anchor="ctr"/>
+          <a:lstStyle/>
+          <a:p>
+            <a:pPr algn="ctr"/>
+          </a:p>
+        </p:txBody>
+      </p:sp>
+      <p:sp>
+        <p:nvSpPr>
+          <p:cNvPr id="17" name="環ラベル_地域"/>
+          <p:cNvSpPr txBox="1"/>
+          <p:nvPr/>
+        </p:nvSpPr>
+        <p:spPr>
+          <a:xfrm rot="19800000">
+            <a:off x="6416656" y="5022766"/>
+            <a:ext cx="1057109" cy="253706"/>
+          </a:xfrm>
+          <a:prstGeom prst="rect">
+            <a:avLst/>
+          </a:prstGeom>
+          <a:noFill/>
+        </p:spPr>
+        <p:txBody>
+          <a:bodyPr wrap="square" lIns="0" rIns="0" tIns="0" bIns="0" anchor="ctr">
+            <a:spAutoFit/>
+          </a:bodyPr>
+          <a:lstStyle/>
+          <a:p>
+            <a:pPr algn="ctr"/>
+            <a:r>
+              <a:rPr sz="1498" b="1" spc="200">
+                <a:solidFill>
+                  <a:srgbClr val="FFFFFF"/>
+                </a:solidFill>
+                <a:latin typeface="游ゴシック"/>
+                <a:ea typeface="游ゴシック"/>
+                <a:cs typeface="游ゴシック"/>
+              </a:rPr>
+              <a:t>地域</a:t>
+            </a:r>
+          </a:p>
+        </p:txBody>
+      </p:sp>
+      <p:sp>
+        <p:nvSpPr>
+          <p:cNvPr id="18" name="環_大学"/>
+          <p:cNvSpPr/>
+          <p:nvPr/>
+        </p:nvSpPr>
+        <p:spPr>
+          <a:xfrm>
+            <a:off x="4108633" y="1691375"/>
+            <a:ext cx="3974732" cy="3974732"/>
+          </a:xfrm>
+          <a:prstGeom prst="blockArc">
+            <a:avLst>
+              <a:gd name="adj1" fmla="val 5556000"/>
+              <a:gd name="adj2" fmla="val 8844000"/>
+              <a:gd name="adj3" fmla="val 14539"/>
+            </a:avLst>
+          </a:prstGeom>
+          <a:solidFill>
+            <a:srgbClr val="54C5AF"/>
+          </a:solidFill>
+          <a:ln>
+            <a:noFill/>
+          </a:ln>
+          <a:effectLst/>
+        </p:spPr>
+        <p:style>
+          <a:lnRef idx="1">
+            <a:schemeClr val="accent1"/>
+          </a:lnRef>
+          <a:fillRef idx="3">
+            <a:schemeClr val="accent1"/>
+          </a:fillRef>
+          <a:effectRef idx="0">
+            <a:schemeClr val="accent1"/>
+          </a:effectRef>
+          <a:fontRef idx="minor">
+            <a:schemeClr val="lt1"/>
+          </a:fontRef>
+        </p:style>
+        <p:txBody>
+          <a:bodyPr rtlCol="0" anchor="ctr"/>
+          <a:lstStyle/>
+          <a:p>
+            <a:pPr algn="ctr"/>
+          </a:p>
+        </p:txBody>
+      </p:sp>
+      <p:sp>
+        <p:nvSpPr>
+          <p:cNvPr id="19" name="環ラベル_大学"/>
+          <p:cNvSpPr txBox="1"/>
+          <p:nvPr/>
+        </p:nvSpPr>
+        <p:spPr>
+          <a:xfrm rot="1800000">
+            <a:off x="4718233" y="5022766"/>
+            <a:ext cx="1057109" cy="253706"/>
+          </a:xfrm>
+          <a:prstGeom prst="rect">
+            <a:avLst/>
+          </a:prstGeom>
+          <a:noFill/>
+        </p:spPr>
+        <p:txBody>
+          <a:bodyPr wrap="square" lIns="0" rIns="0" tIns="0" bIns="0" anchor="ctr">
+            <a:spAutoFit/>
+          </a:bodyPr>
+          <a:lstStyle/>
+          <a:p>
+            <a:pPr algn="ctr"/>
+            <a:r>
+              <a:rPr sz="1498" b="1" spc="200">
+                <a:solidFill>
+                  <a:srgbClr val="FFFFFF"/>
+                </a:solidFill>
+                <a:latin typeface="游ゴシック"/>
+                <a:ea typeface="游ゴシック"/>
+                <a:cs typeface="游ゴシック"/>
+              </a:rPr>
+              <a:t>大学</a:t>
+            </a:r>
+          </a:p>
+        </p:txBody>
+      </p:sp>
+      <p:sp>
+        <p:nvSpPr>
+          <p:cNvPr id="20" name="環_専門学校"/>
+          <p:cNvSpPr/>
+          <p:nvPr/>
+        </p:nvSpPr>
+        <p:spPr>
+          <a:xfrm>
+            <a:off x="4108633" y="1691375"/>
+            <a:ext cx="3974732" cy="3974732"/>
+          </a:xfrm>
+          <a:prstGeom prst="blockArc">
+            <a:avLst>
+              <a:gd name="adj1" fmla="val 9156000"/>
+              <a:gd name="adj2" fmla="val 12443999"/>
+              <a:gd name="adj3" fmla="val 14539"/>
+            </a:avLst>
+          </a:prstGeom>
+          <a:solidFill>
+            <a:srgbClr val="3FB39D"/>
+          </a:solidFill>
+          <a:ln>
+            <a:noFill/>
+          </a:ln>
+          <a:effectLst/>
+        </p:spPr>
+        <p:style>
+          <a:lnRef idx="1">
+            <a:schemeClr val="accent1"/>
+          </a:lnRef>
+          <a:fillRef idx="3">
+            <a:schemeClr val="accent1"/>
+          </a:fillRef>
+          <a:effectRef idx="0">
+            <a:schemeClr val="accent1"/>
+          </a:effectRef>
+          <a:fontRef idx="minor">
+            <a:schemeClr val="lt1"/>
+          </a:fontRef>
+        </p:style>
+        <p:txBody>
+          <a:bodyPr rtlCol="0" anchor="ctr"/>
+          <a:lstStyle/>
+          <a:p>
+            <a:pPr algn="ctr"/>
+          </a:p>
+        </p:txBody>
+      </p:sp>
+      <p:sp>
+        <p:nvSpPr>
+          <p:cNvPr id="21" name="環ラベル_専門学校"/>
+          <p:cNvSpPr txBox="1"/>
+          <p:nvPr/>
+        </p:nvSpPr>
+        <p:spPr>
+          <a:xfrm rot="16200000">
+            <a:off x="3869021" y="3551889"/>
+            <a:ext cx="1057109" cy="253706"/>
+          </a:xfrm>
+          <a:prstGeom prst="rect">
+            <a:avLst/>
+          </a:prstGeom>
+          <a:noFill/>
+        </p:spPr>
+        <p:txBody>
+          <a:bodyPr wrap="square" lIns="0" rIns="0" tIns="0" bIns="0" anchor="ctr">
+            <a:spAutoFit/>
+          </a:bodyPr>
+          <a:lstStyle/>
+          <a:p>
+            <a:pPr algn="ctr"/>
+            <a:r>
+              <a:rPr sz="1331" b="1" spc="200">
+                <a:solidFill>
+                  <a:srgbClr val="FFFFFF"/>
+                </a:solidFill>
+                <a:latin typeface="游ゴシック"/>
+                <a:ea typeface="游ゴシック"/>
+                <a:cs typeface="游ゴシック"/>
+              </a:rPr>
+              <a:t>専門学校</a:t>
+            </a:r>
+          </a:p>
+        </p:txBody>
+      </p:sp>
+      <p:sp>
+        <p:nvSpPr>
+          <p:cNvPr id="22" name="環_高校"/>
+          <p:cNvSpPr/>
+          <p:nvPr/>
+        </p:nvSpPr>
+        <p:spPr>
+          <a:xfrm>
+            <a:off x="4108633" y="1691375"/>
+            <a:ext cx="3974732" cy="3974732"/>
+          </a:xfrm>
+          <a:prstGeom prst="blockArc">
+            <a:avLst>
+              <a:gd name="adj1" fmla="val 12756000"/>
+              <a:gd name="adj2" fmla="val 16043999"/>
+              <a:gd name="adj3" fmla="val 14539"/>
+            </a:avLst>
+          </a:prstGeom>
+          <a:solidFill>
+            <a:srgbClr val="86D6C4"/>
+          </a:solidFill>
+          <a:ln>
+            <a:noFill/>
+          </a:ln>
+          <a:effectLst/>
+        </p:spPr>
+        <p:style>
+          <a:lnRef idx="1">
+            <a:schemeClr val="accent1"/>
+          </a:lnRef>
+          <a:fillRef idx="3">
+            <a:schemeClr val="accent1"/>
+          </a:fillRef>
+          <a:effectRef idx="0">
+            <a:schemeClr val="accent1"/>
+          </a:effectRef>
+          <a:fontRef idx="minor">
+            <a:schemeClr val="lt1"/>
+          </a:fontRef>
+        </p:style>
+        <p:txBody>
+          <a:bodyPr rtlCol="0" anchor="ctr"/>
+          <a:lstStyle/>
+          <a:p>
+            <a:pPr algn="ctr"/>
+          </a:p>
+        </p:txBody>
+      </p:sp>
+      <p:sp>
+        <p:nvSpPr>
+          <p:cNvPr id="23" name="環ラベル_高校"/>
+          <p:cNvSpPr txBox="1"/>
+          <p:nvPr/>
+        </p:nvSpPr>
+        <p:spPr>
+          <a:xfrm rot="19800000">
+            <a:off x="4718233" y="2081011"/>
+            <a:ext cx="1057109" cy="253706"/>
+          </a:xfrm>
+          <a:prstGeom prst="rect">
+            <a:avLst/>
+          </a:prstGeom>
+          <a:noFill/>
+        </p:spPr>
+        <p:txBody>
+          <a:bodyPr wrap="square" lIns="0" rIns="0" tIns="0" bIns="0" anchor="ctr">
+            <a:spAutoFit/>
+          </a:bodyPr>
+          <a:lstStyle/>
+          <a:p>
+            <a:pPr algn="ctr"/>
+            <a:r>
+              <a:rPr sz="1498" b="1" spc="200">
+                <a:solidFill>
+                  <a:srgbClr val="FFFFFF"/>
+                </a:solidFill>
+                <a:latin typeface="游ゴシック"/>
+                <a:ea typeface="游ゴシック"/>
+                <a:cs typeface="游ゴシック"/>
+              </a:rPr>
+              <a:t>高校</a:t>
+            </a:r>
+          </a:p>
+        </p:txBody>
+      </p:sp>
+      <p:sp>
+        <p:nvSpPr>
+          <p:cNvPr id="24" name="循環マーク白"/>
+          <p:cNvSpPr/>
+          <p:nvPr/>
+        </p:nvSpPr>
+        <p:spPr>
+          <a:xfrm>
+            <a:off x="6004383" y="1888702"/>
+            <a:ext cx="183232" cy="183232"/>
+          </a:xfrm>
+          <a:prstGeom prst="ellipse">
+            <a:avLst/>
+          </a:prstGeom>
+          <a:solidFill>
+            <a:srgbClr val="FFFFFF"/>
+          </a:solidFill>
+          <a:ln>
+            <a:noFill/>
+          </a:ln>
+          <a:effectLst/>
+        </p:spPr>
+        <p:style>
+          <a:lnRef idx="1">
+            <a:schemeClr val="accent1"/>
+          </a:lnRef>
+          <a:fillRef idx="3">
+            <a:schemeClr val="accent1"/>
+          </a:fillRef>
+          <a:effectRef idx="0">
+            <a:schemeClr val="accent1"/>
+          </a:effectRef>
+          <a:fontRef idx="minor">
+            <a:schemeClr val="lt1"/>
+          </a:fontRef>
+        </p:style>
+        <p:txBody>
+          <a:bodyPr rtlCol="0" anchor="ctr"/>
+          <a:lstStyle/>
+          <a:p>
+            <a:pPr algn="ctr"/>
+          </a:p>
+        </p:txBody>
+      </p:sp>
+      <p:sp>
+        <p:nvSpPr>
+          <p:cNvPr id="25" name="循環マーク矢印"/>
+          <p:cNvSpPr/>
+          <p:nvPr/>
+        </p:nvSpPr>
+        <p:spPr>
+          <a:xfrm>
+            <a:off x="6067810" y="1952129"/>
+            <a:ext cx="84569" cy="56379"/>
+          </a:xfrm>
+          <a:custGeom>
+            <a:avLst/>
+            <a:gdLst/>
+            <a:ahLst/>
+            <a:cxnLst/>
+            <a:rect l="l" t="t" r="r" b="b"/>
+            <a:pathLst>
+              <a:path w="84569" h="56379">
+                <a:moveTo>
+                  <a:pt x="84569" y="28190"/>
+                </a:moveTo>
+                <a:lnTo>
+                  <a:pt x="0" y="56379"/>
+                </a:lnTo>
+                <a:lnTo>
+                  <a:pt x="0" y="0"/>
+                </a:lnTo>
+                <a:close/>
+              </a:path>
+            </a:pathLst>
+          </a:custGeom>
+          <a:solidFill>
+            <a:srgbClr val="2E9E8A"/>
+          </a:solidFill>
+          <a:ln>
+            <a:noFill/>
+          </a:ln>
+          <a:effectLst/>
+        </p:spPr>
+        <p:style>
+          <a:lnRef idx="1">
+            <a:schemeClr val="accent1"/>
+          </a:lnRef>
+          <a:fillRef idx="3">
+            <a:schemeClr val="accent1"/>
+          </a:fillRef>
+          <a:effectRef idx="0">
+            <a:schemeClr val="accent1"/>
+          </a:effectRef>
+          <a:fontRef idx="minor">
+            <a:schemeClr val="lt1"/>
+          </a:fontRef>
+        </p:style>
+        <p:txBody>
+          <a:bodyPr rtlCol="0" anchor="ctr"/>
+          <a:lstStyle/>
+          <a:p>
+            <a:pPr algn="ctr"/>
+          </a:p>
+        </p:txBody>
+      </p:sp>
+      <p:sp>
+        <p:nvSpPr>
+          <p:cNvPr id="26" name="循環マーク白"/>
+          <p:cNvSpPr/>
+          <p:nvPr/>
+        </p:nvSpPr>
+        <p:spPr>
+          <a:xfrm>
+            <a:off x="7475261" y="2737914"/>
+            <a:ext cx="183232" cy="183232"/>
+          </a:xfrm>
+          <a:prstGeom prst="ellipse">
+            <a:avLst/>
+          </a:prstGeom>
+          <a:solidFill>
+            <a:srgbClr val="FFFFFF"/>
+          </a:solidFill>
+          <a:ln>
+            <a:noFill/>
+          </a:ln>
+          <a:effectLst/>
+        </p:spPr>
+        <p:style>
+          <a:lnRef idx="1">
+            <a:schemeClr val="accent1"/>
+          </a:lnRef>
+          <a:fillRef idx="3">
+            <a:schemeClr val="accent1"/>
+          </a:fillRef>
+          <a:effectRef idx="0">
+            <a:schemeClr val="accent1"/>
+          </a:effectRef>
+          <a:fontRef idx="minor">
+            <a:schemeClr val="lt1"/>
+          </a:fontRef>
+        </p:style>
+        <p:txBody>
+          <a:bodyPr rtlCol="0" anchor="ctr"/>
+          <a:lstStyle/>
+          <a:p>
+            <a:pPr algn="ctr"/>
+          </a:p>
+        </p:txBody>
+      </p:sp>
+      <p:sp>
+        <p:nvSpPr>
+          <p:cNvPr id="27" name="循環マーク矢印"/>
+          <p:cNvSpPr/>
+          <p:nvPr/>
+        </p:nvSpPr>
+        <p:spPr>
+          <a:xfrm>
+            <a:off x="7528369" y="2791022"/>
+            <a:ext cx="66698" cy="87334"/>
+          </a:xfrm>
+          <a:custGeom>
+            <a:avLst/>
+            <a:gdLst/>
+            <a:ahLst/>
+            <a:cxnLst/>
+            <a:rect l="l" t="t" r="r" b="b"/>
+            <a:pathLst>
+              <a:path w="66698" h="87334">
+                <a:moveTo>
+                  <a:pt x="66698" y="87334"/>
+                </a:moveTo>
+                <a:lnTo>
+                  <a:pt x="0" y="28190"/>
+                </a:lnTo>
+                <a:lnTo>
+                  <a:pt x="48826" y="0"/>
+                </a:lnTo>
+                <a:close/>
+              </a:path>
+            </a:pathLst>
+          </a:custGeom>
+          <a:solidFill>
+            <a:srgbClr val="2E9E8A"/>
+          </a:solidFill>
+          <a:ln>
+            <a:noFill/>
+          </a:ln>
+          <a:effectLst/>
+        </p:spPr>
+        <p:style>
+          <a:lnRef idx="1">
+            <a:schemeClr val="accent1"/>
+          </a:lnRef>
+          <a:fillRef idx="3">
+            <a:schemeClr val="accent1"/>
+          </a:fillRef>
+          <a:effectRef idx="0">
+            <a:schemeClr val="accent1"/>
+          </a:effectRef>
+          <a:fontRef idx="minor">
+            <a:schemeClr val="lt1"/>
+          </a:fontRef>
+        </p:style>
+        <p:txBody>
+          <a:bodyPr rtlCol="0" anchor="ctr"/>
+          <a:lstStyle/>
+          <a:p>
+            <a:pPr algn="ctr"/>
+          </a:p>
+        </p:txBody>
+      </p:sp>
+      <p:sp>
+        <p:nvSpPr>
+          <p:cNvPr id="28" name="循環マーク白"/>
+          <p:cNvSpPr/>
+          <p:nvPr/>
+        </p:nvSpPr>
+        <p:spPr>
+          <a:xfrm>
+            <a:off x="7475261" y="4436337"/>
+            <a:ext cx="183232" cy="183232"/>
+          </a:xfrm>
+          <a:prstGeom prst="ellipse">
+            <a:avLst/>
+          </a:prstGeom>
+          <a:solidFill>
+            <a:srgbClr val="FFFFFF"/>
+          </a:solidFill>
+          <a:ln>
+            <a:noFill/>
+          </a:ln>
+          <a:effectLst/>
+        </p:spPr>
+        <p:style>
+          <a:lnRef idx="1">
+            <a:schemeClr val="accent1"/>
+          </a:lnRef>
+          <a:fillRef idx="3">
+            <a:schemeClr val="accent1"/>
+          </a:fillRef>
+          <a:effectRef idx="0">
+            <a:schemeClr val="accent1"/>
+          </a:effectRef>
+          <a:fontRef idx="minor">
+            <a:schemeClr val="lt1"/>
+          </a:fontRef>
+        </p:style>
+        <p:txBody>
+          <a:bodyPr rtlCol="0" anchor="ctr"/>
+          <a:lstStyle/>
+          <a:p>
+            <a:pPr algn="ctr"/>
+          </a:p>
+        </p:txBody>
+      </p:sp>
+      <p:sp>
+        <p:nvSpPr>
+          <p:cNvPr id="29" name="循環マーク矢印"/>
+          <p:cNvSpPr/>
+          <p:nvPr/>
+        </p:nvSpPr>
+        <p:spPr>
+          <a:xfrm>
+            <a:off x="7538687" y="4489446"/>
+            <a:ext cx="66698" cy="87333"/>
+          </a:xfrm>
+          <a:custGeom>
+            <a:avLst/>
+            <a:gdLst/>
+            <a:ahLst/>
+            <a:cxnLst/>
+            <a:rect l="l" t="t" r="r" b="b"/>
+            <a:pathLst>
+              <a:path w="66698" h="87333">
+                <a:moveTo>
+                  <a:pt x="0" y="87333"/>
+                </a:moveTo>
+                <a:lnTo>
+                  <a:pt x="17872" y="0"/>
+                </a:lnTo>
+                <a:lnTo>
+                  <a:pt x="66698" y="28189"/>
+                </a:lnTo>
+                <a:close/>
+              </a:path>
+            </a:pathLst>
+          </a:custGeom>
+          <a:solidFill>
+            <a:srgbClr val="2E9E8A"/>
+          </a:solidFill>
+          <a:ln>
+            <a:noFill/>
+          </a:ln>
+          <a:effectLst/>
+        </p:spPr>
+        <p:style>
+          <a:lnRef idx="1">
+            <a:schemeClr val="accent1"/>
+          </a:lnRef>
+          <a:fillRef idx="3">
+            <a:schemeClr val="accent1"/>
+          </a:fillRef>
+          <a:effectRef idx="0">
+            <a:schemeClr val="accent1"/>
+          </a:effectRef>
+          <a:fontRef idx="minor">
+            <a:schemeClr val="lt1"/>
+          </a:fontRef>
+        </p:style>
+        <p:txBody>
+          <a:bodyPr rtlCol="0" anchor="ctr"/>
+          <a:lstStyle/>
+          <a:p>
+            <a:pPr algn="ctr"/>
+          </a:p>
+        </p:txBody>
+      </p:sp>
+      <p:sp>
+        <p:nvSpPr>
+          <p:cNvPr id="30" name="循環マーク白"/>
+          <p:cNvSpPr/>
+          <p:nvPr/>
+        </p:nvSpPr>
+        <p:spPr>
+          <a:xfrm>
+            <a:off x="6004383" y="5285549"/>
+            <a:ext cx="183232" cy="183232"/>
+          </a:xfrm>
+          <a:prstGeom prst="ellipse">
+            <a:avLst/>
+          </a:prstGeom>
+          <a:solidFill>
+            <a:srgbClr val="FFFFFF"/>
+          </a:solidFill>
+          <a:ln>
+            <a:noFill/>
+          </a:ln>
+          <a:effectLst/>
+        </p:spPr>
+        <p:style>
+          <a:lnRef idx="1">
+            <a:schemeClr val="accent1"/>
+          </a:lnRef>
+          <a:fillRef idx="3">
+            <a:schemeClr val="accent1"/>
+          </a:fillRef>
+          <a:effectRef idx="0">
+            <a:schemeClr val="accent1"/>
+          </a:effectRef>
+          <a:fontRef idx="minor">
+            <a:schemeClr val="lt1"/>
+          </a:fontRef>
+        </p:style>
+        <p:txBody>
+          <a:bodyPr rtlCol="0" anchor="ctr"/>
+          <a:lstStyle/>
+          <a:p>
+            <a:pPr algn="ctr"/>
+          </a:p>
+        </p:txBody>
+      </p:sp>
+      <p:sp>
+        <p:nvSpPr>
+          <p:cNvPr id="31" name="循環マーク矢印"/>
+          <p:cNvSpPr/>
+          <p:nvPr/>
+        </p:nvSpPr>
+        <p:spPr>
+          <a:xfrm>
+            <a:off x="6039620" y="5348975"/>
+            <a:ext cx="84569" cy="56379"/>
+          </a:xfrm>
+          <a:custGeom>
+            <a:avLst/>
+            <a:gdLst/>
+            <a:ahLst/>
+            <a:cxnLst/>
+            <a:rect l="l" t="t" r="r" b="b"/>
+            <a:pathLst>
+              <a:path w="84569" h="56379">
+                <a:moveTo>
+                  <a:pt x="0" y="28190"/>
+                </a:moveTo>
+                <a:lnTo>
+                  <a:pt x="84569" y="0"/>
+                </a:lnTo>
+                <a:lnTo>
+                  <a:pt x="84569" y="56379"/>
+                </a:lnTo>
+                <a:close/>
+              </a:path>
+            </a:pathLst>
+          </a:custGeom>
+          <a:solidFill>
+            <a:srgbClr val="2E9E8A"/>
+          </a:solidFill>
+          <a:ln>
+            <a:noFill/>
+          </a:ln>
+          <a:effectLst/>
+        </p:spPr>
+        <p:style>
+          <a:lnRef idx="1">
+            <a:schemeClr val="accent1"/>
+          </a:lnRef>
+          <a:fillRef idx="3">
+            <a:schemeClr val="accent1"/>
+          </a:fillRef>
+          <a:effectRef idx="0">
+            <a:schemeClr val="accent1"/>
+          </a:effectRef>
+          <a:fontRef idx="minor">
+            <a:schemeClr val="lt1"/>
+          </a:fontRef>
+        </p:style>
+        <p:txBody>
+          <a:bodyPr rtlCol="0" anchor="ctr"/>
+          <a:lstStyle/>
+          <a:p>
+            <a:pPr algn="ctr"/>
+          </a:p>
+        </p:txBody>
+      </p:sp>
+      <p:sp>
+        <p:nvSpPr>
+          <p:cNvPr id="32" name="循環マーク白"/>
+          <p:cNvSpPr/>
+          <p:nvPr/>
+        </p:nvSpPr>
+        <p:spPr>
+          <a:xfrm>
+            <a:off x="4533506" y="4436337"/>
+            <a:ext cx="183232" cy="183232"/>
+          </a:xfrm>
+          <a:prstGeom prst="ellipse">
+            <a:avLst/>
+          </a:prstGeom>
+          <a:solidFill>
+            <a:srgbClr val="FFFFFF"/>
+          </a:solidFill>
+          <a:ln>
+            <a:noFill/>
+          </a:ln>
+          <a:effectLst/>
+        </p:spPr>
+        <p:style>
+          <a:lnRef idx="1">
+            <a:schemeClr val="accent1"/>
+          </a:lnRef>
+          <a:fillRef idx="3">
+            <a:schemeClr val="accent1"/>
+          </a:fillRef>
+          <a:effectRef idx="0">
+            <a:schemeClr val="accent1"/>
+          </a:effectRef>
+          <a:fontRef idx="minor">
+            <a:schemeClr val="lt1"/>
+          </a:fontRef>
+        </p:style>
+        <p:txBody>
+          <a:bodyPr rtlCol="0" anchor="ctr"/>
+          <a:lstStyle/>
+          <a:p>
+            <a:pPr algn="ctr"/>
+          </a:p>
+        </p:txBody>
+      </p:sp>
+      <p:sp>
+        <p:nvSpPr>
+          <p:cNvPr id="33" name="循環マーク矢印"/>
+          <p:cNvSpPr/>
+          <p:nvPr/>
+        </p:nvSpPr>
+        <p:spPr>
+          <a:xfrm>
+            <a:off x="4596932" y="4479127"/>
+            <a:ext cx="66698" cy="87334"/>
+          </a:xfrm>
+          <a:custGeom>
+            <a:avLst/>
+            <a:gdLst/>
+            <a:ahLst/>
+            <a:cxnLst/>
+            <a:rect l="l" t="t" r="r" b="b"/>
+            <a:pathLst>
+              <a:path w="66698" h="87334">
+                <a:moveTo>
+                  <a:pt x="0" y="0"/>
+                </a:moveTo>
+                <a:lnTo>
+                  <a:pt x="66698" y="59144"/>
+                </a:lnTo>
+                <a:lnTo>
+                  <a:pt x="17872" y="87334"/>
+                </a:lnTo>
+                <a:close/>
+              </a:path>
+            </a:pathLst>
+          </a:custGeom>
+          <a:solidFill>
+            <a:srgbClr val="2E9E8A"/>
+          </a:solidFill>
+          <a:ln>
+            <a:noFill/>
+          </a:ln>
+          <a:effectLst/>
+        </p:spPr>
+        <p:style>
+          <a:lnRef idx="1">
+            <a:schemeClr val="accent1"/>
+          </a:lnRef>
+          <a:fillRef idx="3">
+            <a:schemeClr val="accent1"/>
+          </a:fillRef>
+          <a:effectRef idx="0">
+            <a:schemeClr val="accent1"/>
+          </a:effectRef>
+          <a:fontRef idx="minor">
+            <a:schemeClr val="lt1"/>
+          </a:fontRef>
+        </p:style>
+        <p:txBody>
+          <a:bodyPr rtlCol="0" anchor="ctr"/>
+          <a:lstStyle/>
+          <a:p>
+            <a:pPr algn="ctr"/>
+          </a:p>
+        </p:txBody>
+      </p:sp>
+      <p:sp>
+        <p:nvSpPr>
+          <p:cNvPr id="34" name="循環マーク白"/>
+          <p:cNvSpPr/>
+          <p:nvPr/>
+        </p:nvSpPr>
+        <p:spPr>
+          <a:xfrm>
+            <a:off x="4533506" y="2737914"/>
+            <a:ext cx="183232" cy="183232"/>
+          </a:xfrm>
+          <a:prstGeom prst="ellipse">
+            <a:avLst/>
+          </a:prstGeom>
+          <a:solidFill>
+            <a:srgbClr val="FFFFFF"/>
+          </a:solidFill>
+          <a:ln>
+            <a:noFill/>
+          </a:ln>
+          <a:effectLst/>
+        </p:spPr>
+        <p:style>
+          <a:lnRef idx="1">
+            <a:schemeClr val="accent1"/>
+          </a:lnRef>
+          <a:fillRef idx="3">
+            <a:schemeClr val="accent1"/>
+          </a:fillRef>
+          <a:effectRef idx="0">
+            <a:schemeClr val="accent1"/>
+          </a:effectRef>
+          <a:fontRef idx="minor">
+            <a:schemeClr val="lt1"/>
+          </a:fontRef>
+        </p:style>
+        <p:txBody>
+          <a:bodyPr rtlCol="0" anchor="ctr"/>
+          <a:lstStyle/>
+          <a:p>
+            <a:pPr algn="ctr"/>
+          </a:p>
+        </p:txBody>
+      </p:sp>
+      <p:sp>
+        <p:nvSpPr>
+          <p:cNvPr id="35" name="循環マーク矢印"/>
+          <p:cNvSpPr/>
+          <p:nvPr/>
+        </p:nvSpPr>
+        <p:spPr>
+          <a:xfrm>
+            <a:off x="4586614" y="2780704"/>
+            <a:ext cx="66698" cy="87334"/>
+          </a:xfrm>
+          <a:custGeom>
+            <a:avLst/>
+            <a:gdLst/>
+            <a:ahLst/>
+            <a:cxnLst/>
+            <a:rect l="l" t="t" r="r" b="b"/>
+            <a:pathLst>
+              <a:path w="66698" h="87334">
+                <a:moveTo>
+                  <a:pt x="66698" y="0"/>
+                </a:moveTo>
+                <a:lnTo>
+                  <a:pt x="48826" y="87334"/>
+                </a:lnTo>
+                <a:lnTo>
+                  <a:pt x="0" y="59144"/>
+                </a:lnTo>
+                <a:close/>
+              </a:path>
+            </a:pathLst>
+          </a:custGeom>
+          <a:solidFill>
+            <a:srgbClr val="2E9E8A"/>
+          </a:solidFill>
+          <a:ln>
+            <a:noFill/>
+          </a:ln>
+          <a:effectLst/>
+        </p:spPr>
+        <p:style>
+          <a:lnRef idx="1">
+            <a:schemeClr val="accent1"/>
+          </a:lnRef>
+          <a:fillRef idx="3">
+            <a:schemeClr val="accent1"/>
+          </a:fillRef>
+          <a:effectRef idx="0">
+            <a:schemeClr val="accent1"/>
+          </a:effectRef>
+          <a:fontRef idx="minor">
+            <a:schemeClr val="lt1"/>
+          </a:fontRef>
+        </p:style>
+        <p:txBody>
+          <a:bodyPr rtlCol="0" anchor="ctr"/>
+          <a:lstStyle/>
+          <a:p>
+            <a:pPr algn="ctr"/>
+          </a:p>
+        </p:txBody>
+      </p:sp>
+      <p:cxnSp>
+        <p:nvCxnSpPr>
+          <p:cNvPr id="36" name="接続線_エフビー介護サービス"/>
+          <p:cNvCxnSpPr/>
+          <p:nvPr/>
+        </p:nvCxnSpPr>
+        <p:spPr>
+          <a:xfrm flipH="1">
+            <a:off x="7355100" y="2015556"/>
+            <a:ext cx="1003115" cy="0"/>
+          </a:xfrm>
+          <a:prstGeom prst="line">
+            <a:avLst/>
+          </a:prstGeom>
+          <a:ln w="22860">
+            <a:solidFill>
+              <a:srgbClr val="F28C3C"/>
+            </a:solidFill>
+          </a:ln>
+        </p:spPr>
+        <p:style>
+          <a:lnRef idx="2">
+            <a:schemeClr val="accent1"/>
+          </a:lnRef>
+          <a:fillRef idx="0">
+            <a:schemeClr val="accent1"/>
+          </a:fillRef>
+          <a:effectRef idx="0">
+            <a:schemeClr val="accent1"/>
+          </a:effectRef>
+          <a:fontRef idx="minor">
+            <a:schemeClr val="tx1"/>
+          </a:fontRef>
+        </p:style>
+      </p:cxnSp>
+      <p:sp>
+        <p:nvSpPr>
+          <p:cNvPr id="37" name="Oval 36"/>
+          <p:cNvSpPr/>
+          <p:nvPr/>
+        </p:nvSpPr>
+        <p:spPr>
+          <a:xfrm>
+            <a:off x="7312815" y="1973271"/>
+            <a:ext cx="84568" cy="84568"/>
+          </a:xfrm>
+          <a:prstGeom prst="ellipse">
+            <a:avLst/>
+          </a:prstGeom>
+          <a:solidFill>
+            <a:srgbClr val="F28C3C"/>
+          </a:solidFill>
+          <a:ln>
+            <a:noFill/>
+          </a:ln>
+          <a:effectLst/>
+        </p:spPr>
+        <p:style>
+          <a:lnRef idx="1">
+            <a:schemeClr val="accent1"/>
+          </a:lnRef>
+          <a:fillRef idx="3">
+            <a:schemeClr val="accent1"/>
+          </a:fillRef>
+          <a:effectRef idx="0">
+            <a:schemeClr val="accent1"/>
+          </a:effectRef>
+          <a:fontRef idx="minor">
+            <a:schemeClr val="lt1"/>
+          </a:fontRef>
+        </p:style>
+        <p:txBody>
+          <a:bodyPr rtlCol="0" anchor="ctr"/>
+          <a:lstStyle/>
+          <a:p>
+            <a:pPr algn="ctr"/>
+          </a:p>
+        </p:txBody>
+      </p:sp>
+      <p:sp>
+        <p:nvSpPr>
+          <p:cNvPr id="38" name="カード_エフビー介護サービス"/>
+          <p:cNvSpPr/>
+          <p:nvPr/>
+        </p:nvSpPr>
+        <p:spPr>
+          <a:xfrm>
+            <a:off x="8358215" y="1416527"/>
+            <a:ext cx="3382751" cy="1198057"/>
+          </a:xfrm>
+          <a:prstGeom prst="roundRect">
+            <a:avLst>
+              <a:gd name="adj" fmla="val 13000"/>
+            </a:avLst>
+          </a:prstGeom>
+          <a:solidFill>
+            <a:srgbClr val="FFFFFF"/>
+          </a:solidFill>
+          <a:ln>
+            <a:noFill/>
+          </a:ln>
+          <a:effectLst>
+            <a:outerShdw blurRad="112758" dist="42284" dir="5400000" algn="t" rotWithShape="0">
+              <a:srgbClr val="2E9E8A">
+                <a:alpha val="16000"/>
+              </a:srgbClr>
+            </a:outerShdw>
+          </a:effectLst>
+        </p:spPr>
+        <p:style>
+          <a:lnRef idx="1">
+            <a:schemeClr val="accent1"/>
+          </a:lnRef>
+          <a:fillRef idx="3">
+            <a:schemeClr val="accent1"/>
+          </a:fillRef>
+          <a:effectRef idx="0">
+            <a:schemeClr val="accent1"/>
+          </a:effectRef>
+          <a:fontRef idx="minor">
+            <a:schemeClr val="lt1"/>
+          </a:fontRef>
+        </p:style>
+        <p:txBody>
+          <a:bodyPr rtlCol="0" anchor="ctr"/>
+          <a:lstStyle/>
+          <a:p>
+            <a:pPr algn="ctr"/>
+          </a:p>
+        </p:txBody>
+      </p:sp>
+      <p:sp>
+        <p:nvSpPr>
+          <p:cNvPr id="39" name="カード色バー"/>
+          <p:cNvSpPr/>
+          <p:nvPr/>
+        </p:nvSpPr>
+        <p:spPr>
+          <a:xfrm>
+            <a:off x="8358215" y="1613854"/>
+            <a:ext cx="56379" cy="803403"/>
+          </a:xfrm>
+          <a:prstGeom prst="roundRect">
+            <a:avLst>
+              <a:gd name="adj" fmla="val 50000"/>
+            </a:avLst>
+          </a:prstGeom>
+          <a:solidFill>
+            <a:srgbClr val="F28C3C"/>
+          </a:solidFill>
+          <a:ln>
+            <a:noFill/>
+          </a:ln>
+          <a:effectLst/>
+        </p:spPr>
+        <p:style>
+          <a:lnRef idx="1">
+            <a:schemeClr val="accent1"/>
+          </a:lnRef>
+          <a:fillRef idx="3">
+            <a:schemeClr val="accent1"/>
+          </a:fillRef>
+          <a:effectRef idx="0">
+            <a:schemeClr val="accent1"/>
+          </a:effectRef>
+          <a:fontRef idx="minor">
+            <a:schemeClr val="lt1"/>
+          </a:fontRef>
+        </p:style>
+        <p:txBody>
+          <a:bodyPr rtlCol="0" anchor="ctr"/>
+          <a:lstStyle/>
+          <a:p>
+            <a:pPr algn="ctr"/>
+          </a:p>
+        </p:txBody>
+      </p:sp>
+      <p:sp>
+        <p:nvSpPr>
+          <p:cNvPr id="40" name="名称_エフビー介護サービス"/>
+          <p:cNvSpPr txBox="1"/>
+          <p:nvPr/>
+        </p:nvSpPr>
+        <p:spPr>
+          <a:xfrm>
+            <a:off x="8611921" y="1585664"/>
+            <a:ext cx="2959907" cy="197327"/>
+          </a:xfrm>
+          <a:prstGeom prst="rect">
+            <a:avLst/>
+          </a:prstGeom>
+          <a:noFill/>
+        </p:spPr>
+        <p:txBody>
+          <a:bodyPr wrap="square" lIns="0" rIns="0" tIns="0" bIns="0" anchor="t">
+            <a:spAutoFit/>
+          </a:bodyPr>
+          <a:lstStyle/>
+          <a:p>
+            <a:pPr algn="l"/>
+            <a:r>
+              <a:rPr sz="1165" b="1" spc="100">
+                <a:solidFill>
+                  <a:srgbClr val="5B6B73"/>
+                </a:solidFill>
+                <a:latin typeface="游ゴシック"/>
+                <a:ea typeface="游ゴシック"/>
+                <a:cs typeface="游ゴシック"/>
+              </a:rPr>
+              <a:t>エフビー介護サービス</a:t>
+            </a:r>
+          </a:p>
+        </p:txBody>
+      </p:sp>
+      <p:sp>
+        <p:nvSpPr>
+          <p:cNvPr id="41" name="要点_エフビー介護サービス"/>
+          <p:cNvSpPr txBox="1"/>
+          <p:nvPr/>
+        </p:nvSpPr>
+        <p:spPr>
+          <a:xfrm>
+            <a:off x="8611921" y="1782991"/>
+            <a:ext cx="3030381" cy="295990"/>
+          </a:xfrm>
+          <a:prstGeom prst="rect">
+            <a:avLst/>
+          </a:prstGeom>
+          <a:noFill/>
+        </p:spPr>
+        <p:txBody>
+          <a:bodyPr wrap="square" lIns="0" rIns="0" tIns="0" bIns="0" anchor="t">
+            <a:spAutoFit/>
+          </a:bodyPr>
+          <a:lstStyle/>
+          <a:p>
+            <a:pPr algn="l"/>
+            <a:r>
+              <a:rPr sz="1609" b="1">
+                <a:solidFill>
+                  <a:srgbClr val="C8651A"/>
+                </a:solidFill>
+                <a:latin typeface="游ゴシック"/>
+                <a:ea typeface="游ゴシック"/>
+                <a:cs typeface="游ゴシック"/>
+              </a:rPr>
+              <a:t>営業の差になる</a:t>
+            </a:r>
+          </a:p>
+        </p:txBody>
+      </p:sp>
+      <p:sp>
+        <p:nvSpPr>
+          <p:cNvPr id="42" name="説明_エフビー介護サービス"/>
+          <p:cNvSpPr txBox="1"/>
+          <p:nvPr/>
+        </p:nvSpPr>
+        <p:spPr>
+          <a:xfrm>
+            <a:off x="8611921" y="2121267"/>
+            <a:ext cx="3030381" cy="422843"/>
+          </a:xfrm>
+          <a:prstGeom prst="rect">
+            <a:avLst/>
+          </a:prstGeom>
+          <a:noFill/>
+        </p:spPr>
+        <p:txBody>
+          <a:bodyPr wrap="square" lIns="0" rIns="0" tIns="0" bIns="0" anchor="t">
+            <a:spAutoFit/>
+          </a:bodyPr>
+          <a:lstStyle/>
+          <a:p>
+            <a:pPr algn="l">
+              <a:lnSpc>
+                <a:spcPct val="115000"/>
+              </a:lnSpc>
+            </a:pPr>
+            <a:r>
+              <a:rPr sz="1054" b="0">
+                <a:solidFill>
+                  <a:srgbClr val="26323A"/>
+                </a:solidFill>
+                <a:latin typeface="游ゴシック"/>
+                <a:ea typeface="游ゴシック"/>
+                <a:cs typeface="游ゴシック"/>
+              </a:rPr>
+              <a:t>志と実利で学校から選ばれ、</a:t>
+            </a:r>
+          </a:p>
+          <a:p>
+            <a:pPr algn="l">
+              <a:lnSpc>
+                <a:spcPct val="115000"/>
+              </a:lnSpc>
+            </a:pPr>
+            <a:r>
+              <a:rPr sz="1054" b="0">
+                <a:solidFill>
+                  <a:srgbClr val="26323A"/>
+                </a:solidFill>
+                <a:latin typeface="游ゴシック"/>
+                <a:ea typeface="游ゴシック"/>
+                <a:cs typeface="游ゴシック"/>
+              </a:rPr>
+              <a:t>将来の担い手と出会えます。</a:t>
+            </a:r>
+          </a:p>
+        </p:txBody>
+      </p:sp>
+      <p:cxnSp>
+        <p:nvCxnSpPr>
+          <p:cNvPr id="43" name="接続線_社員"/>
+          <p:cNvCxnSpPr/>
+          <p:nvPr/>
+        </p:nvCxnSpPr>
+        <p:spPr>
+          <a:xfrm flipH="1">
+            <a:off x="8182030" y="3678742"/>
+            <a:ext cx="176185" cy="0"/>
+          </a:xfrm>
+          <a:prstGeom prst="line">
+            <a:avLst/>
+          </a:prstGeom>
+          <a:ln w="22860">
+            <a:solidFill>
+              <a:srgbClr val="F7AB67"/>
+            </a:solidFill>
+          </a:ln>
+        </p:spPr>
+        <p:style>
+          <a:lnRef idx="2">
+            <a:schemeClr val="accent1"/>
+          </a:lnRef>
+          <a:fillRef idx="0">
+            <a:schemeClr val="accent1"/>
+          </a:fillRef>
+          <a:effectRef idx="0">
+            <a:schemeClr val="accent1"/>
+          </a:effectRef>
+          <a:fontRef idx="minor">
+            <a:schemeClr val="tx1"/>
+          </a:fontRef>
+        </p:style>
+      </p:cxnSp>
+      <p:sp>
+        <p:nvSpPr>
+          <p:cNvPr id="44" name="Oval 43"/>
+          <p:cNvSpPr/>
+          <p:nvPr/>
+        </p:nvSpPr>
+        <p:spPr>
+          <a:xfrm>
+            <a:off x="8139745" y="3636457"/>
+            <a:ext cx="84568" cy="84568"/>
+          </a:xfrm>
+          <a:prstGeom prst="ellipse">
+            <a:avLst/>
+          </a:prstGeom>
+          <a:solidFill>
+            <a:srgbClr val="F7AB67"/>
+          </a:solidFill>
+          <a:ln>
+            <a:noFill/>
+          </a:ln>
+          <a:effectLst/>
+        </p:spPr>
+        <p:style>
+          <a:lnRef idx="1">
+            <a:schemeClr val="accent1"/>
+          </a:lnRef>
+          <a:fillRef idx="3">
+            <a:schemeClr val="accent1"/>
+          </a:fillRef>
+          <a:effectRef idx="0">
+            <a:schemeClr val="accent1"/>
+          </a:effectRef>
+          <a:fontRef idx="minor">
+            <a:schemeClr val="lt1"/>
+          </a:fontRef>
+        </p:style>
+        <p:txBody>
+          <a:bodyPr rtlCol="0" anchor="ctr"/>
+          <a:lstStyle/>
+          <a:p>
+            <a:pPr algn="ctr"/>
+          </a:p>
+        </p:txBody>
+      </p:sp>
+      <p:sp>
+        <p:nvSpPr>
+          <p:cNvPr id="45" name="カード_社員"/>
+          <p:cNvSpPr/>
+          <p:nvPr/>
+        </p:nvSpPr>
+        <p:spPr>
+          <a:xfrm>
+            <a:off x="8358215" y="3079713"/>
+            <a:ext cx="3382751" cy="1198057"/>
+          </a:xfrm>
+          <a:prstGeom prst="roundRect">
+            <a:avLst>
+              <a:gd name="adj" fmla="val 13000"/>
+            </a:avLst>
+          </a:prstGeom>
+          <a:solidFill>
+            <a:srgbClr val="FFFFFF"/>
+          </a:solidFill>
+          <a:ln>
+            <a:noFill/>
+          </a:ln>
+          <a:effectLst>
+            <a:outerShdw blurRad="112758" dist="42284" dir="5400000" algn="t" rotWithShape="0">
+              <a:srgbClr val="2E9E8A">
+                <a:alpha val="16000"/>
+              </a:srgbClr>
+            </a:outerShdw>
+          </a:effectLst>
+        </p:spPr>
+        <p:style>
+          <a:lnRef idx="1">
+            <a:schemeClr val="accent1"/>
+          </a:lnRef>
+          <a:fillRef idx="3">
+            <a:schemeClr val="accent1"/>
+          </a:fillRef>
+          <a:effectRef idx="0">
+            <a:schemeClr val="accent1"/>
+          </a:effectRef>
+          <a:fontRef idx="minor">
+            <a:schemeClr val="lt1"/>
+          </a:fontRef>
+        </p:style>
+        <p:txBody>
+          <a:bodyPr rtlCol="0" anchor="ctr"/>
+          <a:lstStyle/>
+          <a:p>
+            <a:pPr algn="ctr"/>
+          </a:p>
+        </p:txBody>
+      </p:sp>
+      <p:sp>
+        <p:nvSpPr>
+          <p:cNvPr id="46" name="カード色バー"/>
+          <p:cNvSpPr/>
+          <p:nvPr/>
+        </p:nvSpPr>
+        <p:spPr>
+          <a:xfrm>
+            <a:off x="8358215" y="3277040"/>
+            <a:ext cx="56379" cy="803403"/>
+          </a:xfrm>
+          <a:prstGeom prst="roundRect">
+            <a:avLst>
+              <a:gd name="adj" fmla="val 50000"/>
+            </a:avLst>
+          </a:prstGeom>
+          <a:solidFill>
+            <a:srgbClr val="F7AB67"/>
+          </a:solidFill>
+          <a:ln>
+            <a:noFill/>
+          </a:ln>
+          <a:effectLst/>
+        </p:spPr>
+        <p:style>
+          <a:lnRef idx="1">
+            <a:schemeClr val="accent1"/>
+          </a:lnRef>
+          <a:fillRef idx="3">
+            <a:schemeClr val="accent1"/>
+          </a:fillRef>
+          <a:effectRef idx="0">
+            <a:schemeClr val="accent1"/>
+          </a:effectRef>
+          <a:fontRef idx="minor">
+            <a:schemeClr val="lt1"/>
+          </a:fontRef>
+        </p:style>
+        <p:txBody>
+          <a:bodyPr rtlCol="0" anchor="ctr"/>
+          <a:lstStyle/>
+          <a:p>
+            <a:pPr algn="ctr"/>
+          </a:p>
+        </p:txBody>
+      </p:sp>
+      <p:sp>
+        <p:nvSpPr>
+          <p:cNvPr id="47" name="名称_社員"/>
+          <p:cNvSpPr txBox="1"/>
+          <p:nvPr/>
+        </p:nvSpPr>
+        <p:spPr>
+          <a:xfrm>
+            <a:off x="8611921" y="3248850"/>
+            <a:ext cx="2959907" cy="197327"/>
+          </a:xfrm>
+          <a:prstGeom prst="rect">
+            <a:avLst/>
+          </a:prstGeom>
+          <a:noFill/>
+        </p:spPr>
+        <p:txBody>
+          <a:bodyPr wrap="square" lIns="0" rIns="0" tIns="0" bIns="0" anchor="t">
+            <a:spAutoFit/>
+          </a:bodyPr>
+          <a:lstStyle/>
+          <a:p>
+            <a:pPr algn="l"/>
+            <a:r>
+              <a:rPr sz="1165" b="1" spc="100">
+                <a:solidFill>
+                  <a:srgbClr val="5B6B73"/>
+                </a:solidFill>
+                <a:latin typeface="游ゴシック"/>
+                <a:ea typeface="游ゴシック"/>
+                <a:cs typeface="游ゴシック"/>
+              </a:rPr>
+              <a:t>社員</a:t>
+            </a:r>
+          </a:p>
+        </p:txBody>
+      </p:sp>
+      <p:sp>
+        <p:nvSpPr>
+          <p:cNvPr id="48" name="要点_社員"/>
+          <p:cNvSpPr txBox="1"/>
+          <p:nvPr/>
+        </p:nvSpPr>
+        <p:spPr>
+          <a:xfrm>
+            <a:off x="8611921" y="3446178"/>
+            <a:ext cx="3030381" cy="295990"/>
+          </a:xfrm>
+          <a:prstGeom prst="rect">
+            <a:avLst/>
+          </a:prstGeom>
+          <a:noFill/>
+        </p:spPr>
+        <p:txBody>
+          <a:bodyPr wrap="square" lIns="0" rIns="0" tIns="0" bIns="0" anchor="t">
+            <a:spAutoFit/>
+          </a:bodyPr>
+          <a:lstStyle/>
+          <a:p>
+            <a:pPr algn="l"/>
+            <a:r>
+              <a:rPr sz="1609" b="1">
+                <a:solidFill>
+                  <a:srgbClr val="C8651A"/>
+                </a:solidFill>
+                <a:latin typeface="游ゴシック"/>
+                <a:ea typeface="游ゴシック"/>
+                <a:cs typeface="游ゴシック"/>
+              </a:rPr>
+              <a:t>学びと生きがいが育つ</a:t>
+            </a:r>
+          </a:p>
+        </p:txBody>
+      </p:sp>
+      <p:sp>
+        <p:nvSpPr>
+          <p:cNvPr id="49" name="説明_社員"/>
+          <p:cNvSpPr txBox="1"/>
+          <p:nvPr/>
+        </p:nvSpPr>
+        <p:spPr>
+          <a:xfrm>
+            <a:off x="8611921" y="3784453"/>
+            <a:ext cx="3030381" cy="422843"/>
+          </a:xfrm>
+          <a:prstGeom prst="rect">
+            <a:avLst/>
+          </a:prstGeom>
+          <a:noFill/>
+        </p:spPr>
+        <p:txBody>
+          <a:bodyPr wrap="square" lIns="0" rIns="0" tIns="0" bIns="0" anchor="t">
+            <a:spAutoFit/>
+          </a:bodyPr>
+          <a:lstStyle/>
+          <a:p>
+            <a:pPr algn="l">
+              <a:lnSpc>
+                <a:spcPct val="115000"/>
+              </a:lnSpc>
+            </a:pPr>
+            <a:r>
+              <a:rPr sz="1054" b="0">
+                <a:solidFill>
+                  <a:srgbClr val="26323A"/>
+                </a:solidFill>
+                <a:latin typeface="游ゴシック"/>
+                <a:ea typeface="游ゴシック"/>
+                <a:cs typeface="游ゴシック"/>
+              </a:rPr>
+              <a:t>学生から学び、仕事の意味を再発見。</a:t>
+            </a:r>
+          </a:p>
+          <a:p>
+            <a:pPr algn="l">
+              <a:lnSpc>
+                <a:spcPct val="115000"/>
+              </a:lnSpc>
+            </a:pPr>
+            <a:r>
+              <a:rPr sz="1054" b="0">
+                <a:solidFill>
+                  <a:srgbClr val="26323A"/>
+                </a:solidFill>
+                <a:latin typeface="游ゴシック"/>
+                <a:ea typeface="游ゴシック"/>
+                <a:cs typeface="游ゴシック"/>
+              </a:rPr>
+              <a:t>利用者の生きがいも育ちます。</a:t>
+            </a:r>
+          </a:p>
+        </p:txBody>
+      </p:sp>
+      <p:cxnSp>
+        <p:nvCxnSpPr>
+          <p:cNvPr id="50" name="接続線_地域"/>
+          <p:cNvCxnSpPr/>
+          <p:nvPr/>
+        </p:nvCxnSpPr>
+        <p:spPr>
+          <a:xfrm flipH="1">
+            <a:off x="7355100" y="5341928"/>
+            <a:ext cx="1003115" cy="0"/>
+          </a:xfrm>
+          <a:prstGeom prst="line">
+            <a:avLst/>
+          </a:prstGeom>
+          <a:ln w="22860">
+            <a:solidFill>
+              <a:srgbClr val="2E9E8A"/>
+            </a:solidFill>
+          </a:ln>
+        </p:spPr>
+        <p:style>
+          <a:lnRef idx="2">
+            <a:schemeClr val="accent1"/>
+          </a:lnRef>
+          <a:fillRef idx="0">
+            <a:schemeClr val="accent1"/>
+          </a:fillRef>
+          <a:effectRef idx="0">
+            <a:schemeClr val="accent1"/>
+          </a:effectRef>
+          <a:fontRef idx="minor">
+            <a:schemeClr val="tx1"/>
+          </a:fontRef>
+        </p:style>
+      </p:cxnSp>
+      <p:sp>
+        <p:nvSpPr>
+          <p:cNvPr id="51" name="Oval 50"/>
+          <p:cNvSpPr/>
+          <p:nvPr/>
+        </p:nvSpPr>
+        <p:spPr>
+          <a:xfrm>
+            <a:off x="7312815" y="5299643"/>
+            <a:ext cx="84568" cy="84568"/>
+          </a:xfrm>
+          <a:prstGeom prst="ellipse">
+            <a:avLst/>
+          </a:prstGeom>
+          <a:solidFill>
+            <a:srgbClr val="2E9E8A"/>
+          </a:solidFill>
+          <a:ln>
+            <a:noFill/>
+          </a:ln>
+          <a:effectLst/>
+        </p:spPr>
+        <p:style>
+          <a:lnRef idx="1">
+            <a:schemeClr val="accent1"/>
+          </a:lnRef>
+          <a:fillRef idx="3">
+            <a:schemeClr val="accent1"/>
+          </a:fillRef>
+          <a:effectRef idx="0">
+            <a:schemeClr val="accent1"/>
+          </a:effectRef>
+          <a:fontRef idx="minor">
+            <a:schemeClr val="lt1"/>
+          </a:fontRef>
+        </p:style>
+        <p:txBody>
+          <a:bodyPr rtlCol="0" anchor="ctr"/>
+          <a:lstStyle/>
+          <a:p>
+            <a:pPr algn="ctr"/>
+          </a:p>
+        </p:txBody>
+      </p:sp>
+      <p:sp>
+        <p:nvSpPr>
+          <p:cNvPr id="52" name="カード_地域"/>
+          <p:cNvSpPr/>
+          <p:nvPr/>
+        </p:nvSpPr>
+        <p:spPr>
+          <a:xfrm>
+            <a:off x="8358215" y="4742899"/>
+            <a:ext cx="3382751" cy="1198057"/>
+          </a:xfrm>
+          <a:prstGeom prst="roundRect">
+            <a:avLst>
+              <a:gd name="adj" fmla="val 13000"/>
+            </a:avLst>
+          </a:prstGeom>
+          <a:solidFill>
+            <a:srgbClr val="FFFFFF"/>
+          </a:solidFill>
+          <a:ln>
+            <a:noFill/>
+          </a:ln>
+          <a:effectLst>
+            <a:outerShdw blurRad="112758" dist="42284" dir="5400000" algn="t" rotWithShape="0">
+              <a:srgbClr val="2E9E8A">
+                <a:alpha val="16000"/>
+              </a:srgbClr>
+            </a:outerShdw>
+          </a:effectLst>
+        </p:spPr>
+        <p:style>
+          <a:lnRef idx="1">
+            <a:schemeClr val="accent1"/>
+          </a:lnRef>
+          <a:fillRef idx="3">
+            <a:schemeClr val="accent1"/>
+          </a:fillRef>
+          <a:effectRef idx="0">
+            <a:schemeClr val="accent1"/>
+          </a:effectRef>
+          <a:fontRef idx="minor">
+            <a:schemeClr val="lt1"/>
+          </a:fontRef>
+        </p:style>
+        <p:txBody>
+          <a:bodyPr rtlCol="0" anchor="ctr"/>
+          <a:lstStyle/>
+          <a:p>
+            <a:pPr algn="ctr"/>
+          </a:p>
+        </p:txBody>
+      </p:sp>
+      <p:sp>
+        <p:nvSpPr>
+          <p:cNvPr id="53" name="カード色バー"/>
+          <p:cNvSpPr/>
+          <p:nvPr/>
+        </p:nvSpPr>
+        <p:spPr>
+          <a:xfrm>
+            <a:off x="8358215" y="4940226"/>
+            <a:ext cx="56379" cy="803403"/>
+          </a:xfrm>
+          <a:prstGeom prst="roundRect">
+            <a:avLst>
+              <a:gd name="adj" fmla="val 50000"/>
+            </a:avLst>
+          </a:prstGeom>
+          <a:solidFill>
+            <a:srgbClr val="2E9E8A"/>
+          </a:solidFill>
+          <a:ln>
+            <a:noFill/>
+          </a:ln>
+          <a:effectLst/>
+        </p:spPr>
+        <p:style>
+          <a:lnRef idx="1">
+            <a:schemeClr val="accent1"/>
+          </a:lnRef>
+          <a:fillRef idx="3">
+            <a:schemeClr val="accent1"/>
+          </a:fillRef>
+          <a:effectRef idx="0">
+            <a:schemeClr val="accent1"/>
+          </a:effectRef>
+          <a:fontRef idx="minor">
+            <a:schemeClr val="lt1"/>
+          </a:fontRef>
+        </p:style>
+        <p:txBody>
+          <a:bodyPr rtlCol="0" anchor="ctr"/>
+          <a:lstStyle/>
+          <a:p>
+            <a:pPr algn="ctr"/>
+          </a:p>
+        </p:txBody>
+      </p:sp>
+      <p:sp>
+        <p:nvSpPr>
+          <p:cNvPr id="54" name="名称_地域"/>
+          <p:cNvSpPr txBox="1"/>
+          <p:nvPr/>
+        </p:nvSpPr>
+        <p:spPr>
+          <a:xfrm>
+            <a:off x="8611921" y="4912036"/>
+            <a:ext cx="2959907" cy="197327"/>
+          </a:xfrm>
+          <a:prstGeom prst="rect">
+            <a:avLst/>
+          </a:prstGeom>
+          <a:noFill/>
+        </p:spPr>
+        <p:txBody>
+          <a:bodyPr wrap="square" lIns="0" rIns="0" tIns="0" bIns="0" anchor="t">
+            <a:spAutoFit/>
+          </a:bodyPr>
+          <a:lstStyle/>
+          <a:p>
+            <a:pPr algn="l"/>
+            <a:r>
+              <a:rPr sz="1165" b="1" spc="100">
+                <a:solidFill>
+                  <a:srgbClr val="5B6B73"/>
+                </a:solidFill>
+                <a:latin typeface="游ゴシック"/>
+                <a:ea typeface="游ゴシック"/>
+                <a:cs typeface="游ゴシック"/>
+              </a:rPr>
+              <a:t>地域</a:t>
+            </a:r>
+          </a:p>
+        </p:txBody>
+      </p:sp>
+      <p:sp>
+        <p:nvSpPr>
+          <p:cNvPr id="55" name="要点_地域"/>
+          <p:cNvSpPr txBox="1"/>
+          <p:nvPr/>
+        </p:nvSpPr>
+        <p:spPr>
+          <a:xfrm>
+            <a:off x="8611921" y="5109364"/>
+            <a:ext cx="3030381" cy="295990"/>
+          </a:xfrm>
+          <a:prstGeom prst="rect">
+            <a:avLst/>
+          </a:prstGeom>
+          <a:noFill/>
+        </p:spPr>
+        <p:txBody>
+          <a:bodyPr wrap="square" lIns="0" rIns="0" tIns="0" bIns="0" anchor="t">
+            <a:spAutoFit/>
+          </a:bodyPr>
+          <a:lstStyle/>
+          <a:p>
+            <a:pPr algn="l"/>
+            <a:r>
+              <a:rPr sz="1609" b="1">
+                <a:solidFill>
+                  <a:srgbClr val="1F7D6C"/>
+                </a:solidFill>
+                <a:latin typeface="游ゴシック"/>
+                <a:ea typeface="游ゴシック"/>
+                <a:cs typeface="游ゴシック"/>
+              </a:rPr>
+              <a:t>担い手とまちの未来</a:t>
+            </a:r>
+          </a:p>
+        </p:txBody>
+      </p:sp>
+      <p:sp>
+        <p:nvSpPr>
+          <p:cNvPr id="56" name="説明_地域"/>
+          <p:cNvSpPr txBox="1"/>
+          <p:nvPr/>
+        </p:nvSpPr>
+        <p:spPr>
+          <a:xfrm>
+            <a:off x="8611921" y="5447639"/>
+            <a:ext cx="3030381" cy="422843"/>
+          </a:xfrm>
+          <a:prstGeom prst="rect">
+            <a:avLst/>
+          </a:prstGeom>
+          <a:noFill/>
+        </p:spPr>
+        <p:txBody>
+          <a:bodyPr wrap="square" lIns="0" rIns="0" tIns="0" bIns="0" anchor="t">
+            <a:spAutoFit/>
+          </a:bodyPr>
+          <a:lstStyle/>
+          <a:p>
+            <a:pPr algn="l">
+              <a:lnSpc>
+                <a:spcPct val="115000"/>
+              </a:lnSpc>
+            </a:pPr>
+            <a:r>
+              <a:rPr sz="1054" b="0">
+                <a:solidFill>
+                  <a:srgbClr val="26323A"/>
+                </a:solidFill>
+                <a:latin typeface="游ゴシック"/>
+                <a:ea typeface="游ゴシック"/>
+                <a:cs typeface="游ゴシック"/>
+              </a:rPr>
+              <a:t>地域を担う人が育ち、</a:t>
+            </a:r>
+          </a:p>
+          <a:p>
+            <a:pPr algn="l">
+              <a:lnSpc>
+                <a:spcPct val="115000"/>
+              </a:lnSpc>
+            </a:pPr>
+            <a:r>
+              <a:rPr sz="1054" b="0">
+                <a:solidFill>
+                  <a:srgbClr val="26323A"/>
+                </a:solidFill>
+                <a:latin typeface="游ゴシック"/>
+                <a:ea typeface="游ゴシック"/>
+                <a:cs typeface="游ゴシック"/>
+              </a:rPr>
+              <a:t>介護の現場が身近になります。</a:t>
+            </a:r>
+          </a:p>
+        </p:txBody>
+      </p:sp>
+      <p:cxnSp>
+        <p:nvCxnSpPr>
+          <p:cNvPr id="57" name="接続線_大学"/>
+          <p:cNvCxnSpPr/>
+          <p:nvPr/>
+        </p:nvCxnSpPr>
+        <p:spPr>
+          <a:xfrm>
+            <a:off x="3833784" y="5341928"/>
+            <a:ext cx="1003115" cy="0"/>
+          </a:xfrm>
+          <a:prstGeom prst="line">
+            <a:avLst/>
+          </a:prstGeom>
+          <a:ln w="22860">
+            <a:solidFill>
+              <a:srgbClr val="54C5AF"/>
+            </a:solidFill>
+          </a:ln>
+        </p:spPr>
+        <p:style>
+          <a:lnRef idx="2">
+            <a:schemeClr val="accent1"/>
+          </a:lnRef>
+          <a:fillRef idx="0">
+            <a:schemeClr val="accent1"/>
+          </a:fillRef>
+          <a:effectRef idx="0">
+            <a:schemeClr val="accent1"/>
+          </a:effectRef>
+          <a:fontRef idx="minor">
+            <a:schemeClr val="tx1"/>
+          </a:fontRef>
+        </p:style>
+      </p:cxnSp>
+      <p:sp>
+        <p:nvSpPr>
+          <p:cNvPr id="58" name="Oval 57"/>
+          <p:cNvSpPr/>
+          <p:nvPr/>
+        </p:nvSpPr>
+        <p:spPr>
+          <a:xfrm>
+            <a:off x="4794615" y="5299643"/>
+            <a:ext cx="84568" cy="84568"/>
+          </a:xfrm>
+          <a:prstGeom prst="ellipse">
+            <a:avLst/>
+          </a:prstGeom>
+          <a:solidFill>
+            <a:srgbClr val="54C5AF"/>
+          </a:solidFill>
+          <a:ln>
+            <a:noFill/>
+          </a:ln>
+          <a:effectLst/>
+        </p:spPr>
+        <p:style>
+          <a:lnRef idx="1">
+            <a:schemeClr val="accent1"/>
+          </a:lnRef>
+          <a:fillRef idx="3">
+            <a:schemeClr val="accent1"/>
+          </a:fillRef>
+          <a:effectRef idx="0">
+            <a:schemeClr val="accent1"/>
+          </a:effectRef>
+          <a:fontRef idx="minor">
+            <a:schemeClr val="lt1"/>
+          </a:fontRef>
+        </p:style>
+        <p:txBody>
+          <a:bodyPr rtlCol="0" anchor="ctr"/>
+          <a:lstStyle/>
+          <a:p>
+            <a:pPr algn="ctr"/>
+          </a:p>
+        </p:txBody>
+      </p:sp>
+      <p:sp>
+        <p:nvSpPr>
+          <p:cNvPr id="59" name="カード_大学"/>
+          <p:cNvSpPr/>
+          <p:nvPr/>
+        </p:nvSpPr>
+        <p:spPr>
+          <a:xfrm>
+            <a:off x="451033" y="4742899"/>
+            <a:ext cx="3382751" cy="1198057"/>
+          </a:xfrm>
+          <a:prstGeom prst="roundRect">
+            <a:avLst>
+              <a:gd name="adj" fmla="val 13000"/>
+            </a:avLst>
+          </a:prstGeom>
+          <a:solidFill>
+            <a:srgbClr val="FFFFFF"/>
+          </a:solidFill>
+          <a:ln>
+            <a:noFill/>
+          </a:ln>
+          <a:effectLst>
+            <a:outerShdw blurRad="112758" dist="42284" dir="5400000" algn="t" rotWithShape="0">
+              <a:srgbClr val="2E9E8A">
+                <a:alpha val="16000"/>
+              </a:srgbClr>
+            </a:outerShdw>
+          </a:effectLst>
+        </p:spPr>
+        <p:style>
+          <a:lnRef idx="1">
+            <a:schemeClr val="accent1"/>
+          </a:lnRef>
+          <a:fillRef idx="3">
+            <a:schemeClr val="accent1"/>
+          </a:fillRef>
+          <a:effectRef idx="0">
+            <a:schemeClr val="accent1"/>
+          </a:effectRef>
+          <a:fontRef idx="minor">
+            <a:schemeClr val="lt1"/>
+          </a:fontRef>
+        </p:style>
+        <p:txBody>
+          <a:bodyPr rtlCol="0" anchor="ctr"/>
+          <a:lstStyle/>
+          <a:p>
+            <a:pPr algn="ctr"/>
+          </a:p>
+        </p:txBody>
+      </p:sp>
+      <p:sp>
+        <p:nvSpPr>
+          <p:cNvPr id="60" name="カード色バー"/>
+          <p:cNvSpPr/>
+          <p:nvPr/>
+        </p:nvSpPr>
+        <p:spPr>
+          <a:xfrm>
+            <a:off x="451033" y="4940226"/>
+            <a:ext cx="56379" cy="803403"/>
+          </a:xfrm>
+          <a:prstGeom prst="roundRect">
+            <a:avLst>
+              <a:gd name="adj" fmla="val 50000"/>
+            </a:avLst>
+          </a:prstGeom>
+          <a:solidFill>
+            <a:srgbClr val="54C5AF"/>
+          </a:solidFill>
+          <a:ln>
+            <a:noFill/>
+          </a:ln>
+          <a:effectLst/>
+        </p:spPr>
+        <p:style>
+          <a:lnRef idx="1">
+            <a:schemeClr val="accent1"/>
+          </a:lnRef>
+          <a:fillRef idx="3">
+            <a:schemeClr val="accent1"/>
+          </a:fillRef>
+          <a:effectRef idx="0">
+            <a:schemeClr val="accent1"/>
+          </a:effectRef>
+          <a:fontRef idx="minor">
+            <a:schemeClr val="lt1"/>
+          </a:fontRef>
+        </p:style>
+        <p:txBody>
+          <a:bodyPr rtlCol="0" anchor="ctr"/>
+          <a:lstStyle/>
+          <a:p>
+            <a:pPr algn="ctr"/>
+          </a:p>
+        </p:txBody>
+      </p:sp>
+      <p:sp>
+        <p:nvSpPr>
+          <p:cNvPr id="61" name="名称_大学"/>
+          <p:cNvSpPr txBox="1"/>
+          <p:nvPr/>
+        </p:nvSpPr>
+        <p:spPr>
+          <a:xfrm>
+            <a:off x="704739" y="4912036"/>
+            <a:ext cx="2959907" cy="197327"/>
+          </a:xfrm>
+          <a:prstGeom prst="rect">
+            <a:avLst/>
+          </a:prstGeom>
+          <a:noFill/>
+        </p:spPr>
+        <p:txBody>
+          <a:bodyPr wrap="square" lIns="0" rIns="0" tIns="0" bIns="0" anchor="t">
+            <a:spAutoFit/>
+          </a:bodyPr>
+          <a:lstStyle/>
+          <a:p>
+            <a:pPr algn="l"/>
+            <a:r>
+              <a:rPr sz="1165" b="1" spc="100">
+                <a:solidFill>
+                  <a:srgbClr val="5B6B73"/>
+                </a:solidFill>
+                <a:latin typeface="游ゴシック"/>
+                <a:ea typeface="游ゴシック"/>
+                <a:cs typeface="游ゴシック"/>
+              </a:rPr>
+              <a:t>大学</a:t>
+            </a:r>
+          </a:p>
+        </p:txBody>
+      </p:sp>
+      <p:sp>
+        <p:nvSpPr>
+          <p:cNvPr id="62" name="要点_大学"/>
+          <p:cNvSpPr txBox="1"/>
+          <p:nvPr/>
+        </p:nvSpPr>
+        <p:spPr>
+          <a:xfrm>
+            <a:off x="704739" y="5109364"/>
+            <a:ext cx="3030381" cy="295990"/>
+          </a:xfrm>
+          <a:prstGeom prst="rect">
+            <a:avLst/>
+          </a:prstGeom>
+          <a:noFill/>
+        </p:spPr>
+        <p:txBody>
+          <a:bodyPr wrap="square" lIns="0" rIns="0" tIns="0" bIns="0" anchor="t">
+            <a:spAutoFit/>
+          </a:bodyPr>
+          <a:lstStyle/>
+          <a:p>
+            <a:pPr algn="l"/>
+            <a:r>
+              <a:rPr sz="1609" b="1">
+                <a:solidFill>
+                  <a:srgbClr val="1F7D6C"/>
+                </a:solidFill>
+                <a:latin typeface="游ゴシック"/>
+                <a:ea typeface="游ゴシック"/>
+                <a:cs typeface="游ゴシック"/>
+              </a:rPr>
+              <a:t>学部・学科の魅力向上</a:t>
+            </a:r>
+          </a:p>
+        </p:txBody>
+      </p:sp>
+      <p:sp>
+        <p:nvSpPr>
+          <p:cNvPr id="63" name="説明_大学"/>
+          <p:cNvSpPr txBox="1"/>
+          <p:nvPr/>
+        </p:nvSpPr>
+        <p:spPr>
+          <a:xfrm>
+            <a:off x="704739" y="5447639"/>
+            <a:ext cx="3030381" cy="422843"/>
+          </a:xfrm>
+          <a:prstGeom prst="rect">
+            <a:avLst/>
+          </a:prstGeom>
+          <a:noFill/>
+        </p:spPr>
+        <p:txBody>
+          <a:bodyPr wrap="square" lIns="0" rIns="0" tIns="0" bIns="0" anchor="t">
+            <a:spAutoFit/>
+          </a:bodyPr>
+          <a:lstStyle/>
+          <a:p>
+            <a:pPr algn="l">
+              <a:lnSpc>
+                <a:spcPct val="115000"/>
+              </a:lnSpc>
+            </a:pPr>
+            <a:r>
+              <a:rPr sz="1054" b="0">
+                <a:solidFill>
+                  <a:srgbClr val="26323A"/>
+                </a:solidFill>
+                <a:latin typeface="游ゴシック"/>
+                <a:ea typeface="游ゴシック"/>
+                <a:cs typeface="游ゴシック"/>
+              </a:rPr>
+              <a:t>魅力的な実習を提供。社会テーマ型</a:t>
+            </a:r>
+          </a:p>
+          <a:p>
+            <a:pPr algn="l">
+              <a:lnSpc>
+                <a:spcPct val="115000"/>
+              </a:lnSpc>
+            </a:pPr>
+            <a:r>
+              <a:rPr sz="1054" b="0">
+                <a:solidFill>
+                  <a:srgbClr val="26323A"/>
+                </a:solidFill>
+                <a:latin typeface="游ゴシック"/>
+                <a:ea typeface="游ゴシック"/>
+                <a:cs typeface="游ゴシック"/>
+              </a:rPr>
+              <a:t>プログラム「STA」で連携します。</a:t>
+            </a:r>
+          </a:p>
+        </p:txBody>
+      </p:sp>
+      <p:cxnSp>
+        <p:nvCxnSpPr>
+          <p:cNvPr id="64" name="接続線_専門学校"/>
+          <p:cNvCxnSpPr/>
+          <p:nvPr/>
+        </p:nvCxnSpPr>
+        <p:spPr>
+          <a:xfrm>
+            <a:off x="3833784" y="3678742"/>
+            <a:ext cx="176185" cy="0"/>
+          </a:xfrm>
+          <a:prstGeom prst="line">
+            <a:avLst/>
+          </a:prstGeom>
+          <a:ln w="22860">
+            <a:solidFill>
+              <a:srgbClr val="3FB39D"/>
+            </a:solidFill>
+          </a:ln>
+        </p:spPr>
+        <p:style>
+          <a:lnRef idx="2">
+            <a:schemeClr val="accent1"/>
+          </a:lnRef>
+          <a:fillRef idx="0">
+            <a:schemeClr val="accent1"/>
+          </a:fillRef>
+          <a:effectRef idx="0">
+            <a:schemeClr val="accent1"/>
+          </a:effectRef>
+          <a:fontRef idx="minor">
+            <a:schemeClr val="tx1"/>
+          </a:fontRef>
+        </p:style>
+      </p:cxnSp>
+      <p:sp>
+        <p:nvSpPr>
+          <p:cNvPr id="65" name="Oval 64"/>
+          <p:cNvSpPr/>
+          <p:nvPr/>
+        </p:nvSpPr>
+        <p:spPr>
+          <a:xfrm>
+            <a:off x="3967685" y="3636457"/>
+            <a:ext cx="84568" cy="84568"/>
+          </a:xfrm>
+          <a:prstGeom prst="ellipse">
+            <a:avLst/>
+          </a:prstGeom>
+          <a:solidFill>
+            <a:srgbClr val="3FB39D"/>
+          </a:solidFill>
+          <a:ln>
+            <a:noFill/>
+          </a:ln>
+          <a:effectLst/>
+        </p:spPr>
+        <p:style>
+          <a:lnRef idx="1">
+            <a:schemeClr val="accent1"/>
+          </a:lnRef>
+          <a:fillRef idx="3">
+            <a:schemeClr val="accent1"/>
+          </a:fillRef>
+          <a:effectRef idx="0">
+            <a:schemeClr val="accent1"/>
+          </a:effectRef>
+          <a:fontRef idx="minor">
+            <a:schemeClr val="lt1"/>
+          </a:fontRef>
+        </p:style>
+        <p:txBody>
+          <a:bodyPr rtlCol="0" anchor="ctr"/>
+          <a:lstStyle/>
+          <a:p>
+            <a:pPr algn="ctr"/>
+          </a:p>
+        </p:txBody>
+      </p:sp>
+      <p:sp>
+        <p:nvSpPr>
+          <p:cNvPr id="66" name="カード_専門学校"/>
+          <p:cNvSpPr/>
+          <p:nvPr/>
+        </p:nvSpPr>
+        <p:spPr>
+          <a:xfrm>
+            <a:off x="451033" y="3079713"/>
+            <a:ext cx="3382751" cy="1198057"/>
+          </a:xfrm>
+          <a:prstGeom prst="roundRect">
+            <a:avLst>
+              <a:gd name="adj" fmla="val 13000"/>
+            </a:avLst>
+          </a:prstGeom>
+          <a:solidFill>
+            <a:srgbClr val="FFFFFF"/>
+          </a:solidFill>
+          <a:ln>
+            <a:noFill/>
+          </a:ln>
+          <a:effectLst>
+            <a:outerShdw blurRad="112758" dist="42284" dir="5400000" algn="t" rotWithShape="0">
+              <a:srgbClr val="2E9E8A">
+                <a:alpha val="16000"/>
+              </a:srgbClr>
+            </a:outerShdw>
+          </a:effectLst>
+        </p:spPr>
+        <p:style>
+          <a:lnRef idx="1">
+            <a:schemeClr val="accent1"/>
+          </a:lnRef>
+          <a:fillRef idx="3">
+            <a:schemeClr val="accent1"/>
+          </a:fillRef>
+          <a:effectRef idx="0">
+            <a:schemeClr val="accent1"/>
+          </a:effectRef>
+          <a:fontRef idx="minor">
+            <a:schemeClr val="lt1"/>
+          </a:fontRef>
+        </p:style>
+        <p:txBody>
+          <a:bodyPr rtlCol="0" anchor="ctr"/>
+          <a:lstStyle/>
+          <a:p>
+            <a:pPr algn="ctr"/>
+          </a:p>
+        </p:txBody>
+      </p:sp>
+      <p:sp>
+        <p:nvSpPr>
+          <p:cNvPr id="67" name="カード色バー"/>
+          <p:cNvSpPr/>
+          <p:nvPr/>
+        </p:nvSpPr>
+        <p:spPr>
+          <a:xfrm>
+            <a:off x="451033" y="3277040"/>
+            <a:ext cx="56379" cy="803403"/>
+          </a:xfrm>
+          <a:prstGeom prst="roundRect">
+            <a:avLst>
+              <a:gd name="adj" fmla="val 50000"/>
+            </a:avLst>
+          </a:prstGeom>
+          <a:solidFill>
+            <a:srgbClr val="3FB39D"/>
+          </a:solidFill>
+          <a:ln>
+            <a:noFill/>
+          </a:ln>
+          <a:effectLst/>
+        </p:spPr>
+        <p:style>
+          <a:lnRef idx="1">
+            <a:schemeClr val="accent1"/>
+          </a:lnRef>
+          <a:fillRef idx="3">
+            <a:schemeClr val="accent1"/>
+          </a:fillRef>
+          <a:effectRef idx="0">
+            <a:schemeClr val="accent1"/>
+          </a:effectRef>
+          <a:fontRef idx="minor">
+            <a:schemeClr val="lt1"/>
+          </a:fontRef>
+        </p:style>
+        <p:txBody>
+          <a:bodyPr rtlCol="0" anchor="ctr"/>
+          <a:lstStyle/>
+          <a:p>
+            <a:pPr algn="ctr"/>
+          </a:p>
+        </p:txBody>
+      </p:sp>
+      <p:sp>
+        <p:nvSpPr>
+          <p:cNvPr id="68" name="名称_専門学校"/>
+          <p:cNvSpPr txBox="1"/>
+          <p:nvPr/>
+        </p:nvSpPr>
+        <p:spPr>
+          <a:xfrm>
+            <a:off x="704739" y="3248850"/>
+            <a:ext cx="2959907" cy="197327"/>
+          </a:xfrm>
+          <a:prstGeom prst="rect">
+            <a:avLst/>
+          </a:prstGeom>
+          <a:noFill/>
+        </p:spPr>
+        <p:txBody>
+          <a:bodyPr wrap="square" lIns="0" rIns="0" tIns="0" bIns="0" anchor="t">
+            <a:spAutoFit/>
+          </a:bodyPr>
+          <a:lstStyle/>
+          <a:p>
+            <a:pPr algn="l"/>
+            <a:r>
+              <a:rPr sz="1165" b="1" spc="100">
+                <a:solidFill>
+                  <a:srgbClr val="5B6B73"/>
+                </a:solidFill>
+                <a:latin typeface="游ゴシック"/>
+                <a:ea typeface="游ゴシック"/>
+                <a:cs typeface="游ゴシック"/>
+              </a:rPr>
+              <a:t>専門学校</a:t>
+            </a:r>
+          </a:p>
+        </p:txBody>
+      </p:sp>
+      <p:sp>
+        <p:nvSpPr>
+          <p:cNvPr id="69" name="要点_専門学校"/>
+          <p:cNvSpPr txBox="1"/>
+          <p:nvPr/>
+        </p:nvSpPr>
+        <p:spPr>
+          <a:xfrm>
+            <a:off x="704739" y="3446178"/>
+            <a:ext cx="3030381" cy="295990"/>
+          </a:xfrm>
+          <a:prstGeom prst="rect">
+            <a:avLst/>
+          </a:prstGeom>
+          <a:noFill/>
+        </p:spPr>
+        <p:txBody>
+          <a:bodyPr wrap="square" lIns="0" rIns="0" tIns="0" bIns="0" anchor="t">
+            <a:spAutoFit/>
+          </a:bodyPr>
+          <a:lstStyle/>
+          <a:p>
+            <a:pPr algn="l"/>
+            <a:r>
+              <a:rPr sz="1609" b="1">
+                <a:solidFill>
+                  <a:srgbClr val="1F7D6C"/>
+                </a:solidFill>
+                <a:latin typeface="游ゴシック"/>
+                <a:ea typeface="游ゴシック"/>
+                <a:cs typeface="游ゴシック"/>
+              </a:rPr>
+              <a:t>実習先の選択肢が広がる</a:t>
+            </a:r>
+          </a:p>
+        </p:txBody>
+      </p:sp>
+      <p:sp>
+        <p:nvSpPr>
+          <p:cNvPr id="70" name="説明_専門学校"/>
+          <p:cNvSpPr txBox="1"/>
+          <p:nvPr/>
+        </p:nvSpPr>
+        <p:spPr>
+          <a:xfrm>
+            <a:off x="704739" y="3784453"/>
+            <a:ext cx="3030381" cy="422843"/>
+          </a:xfrm>
+          <a:prstGeom prst="rect">
+            <a:avLst/>
+          </a:prstGeom>
+          <a:noFill/>
+        </p:spPr>
+        <p:txBody>
+          <a:bodyPr wrap="square" lIns="0" rIns="0" tIns="0" bIns="0" anchor="t">
+            <a:spAutoFit/>
+          </a:bodyPr>
+          <a:lstStyle/>
+          <a:p>
+            <a:pPr algn="l">
+              <a:lnSpc>
+                <a:spcPct val="115000"/>
+              </a:lnSpc>
+            </a:pPr>
+            <a:r>
+              <a:rPr sz="1054" b="0">
+                <a:solidFill>
+                  <a:srgbClr val="26323A"/>
+                </a:solidFill>
+                <a:latin typeface="游ゴシック"/>
+                <a:ea typeface="游ゴシック"/>
+                <a:cs typeface="游ゴシック"/>
+              </a:rPr>
+              <a:t>単位つきの実習先が増え、</a:t>
+            </a:r>
+          </a:p>
+          <a:p>
+            <a:pPr algn="l">
+              <a:lnSpc>
+                <a:spcPct val="115000"/>
+              </a:lnSpc>
+            </a:pPr>
+            <a:r>
+              <a:rPr sz="1054" b="0">
+                <a:solidFill>
+                  <a:srgbClr val="26323A"/>
+                </a:solidFill>
+                <a:latin typeface="游ゴシック"/>
+                <a:ea typeface="游ゴシック"/>
+                <a:cs typeface="游ゴシック"/>
+              </a:rPr>
+              <a:t>介護の学びの入口が広がります。</a:t>
+            </a:r>
+          </a:p>
+        </p:txBody>
+      </p:sp>
+      <p:cxnSp>
+        <p:nvCxnSpPr>
+          <p:cNvPr id="71" name="接続線_高校"/>
+          <p:cNvCxnSpPr/>
+          <p:nvPr/>
+        </p:nvCxnSpPr>
+        <p:spPr>
+          <a:xfrm>
+            <a:off x="3833784" y="2015556"/>
+            <a:ext cx="1003115" cy="0"/>
+          </a:xfrm>
+          <a:prstGeom prst="line">
+            <a:avLst/>
+          </a:prstGeom>
+          <a:ln w="22860">
+            <a:solidFill>
+              <a:srgbClr val="86D6C4"/>
+            </a:solidFill>
+          </a:ln>
+        </p:spPr>
+        <p:style>
+          <a:lnRef idx="2">
+            <a:schemeClr val="accent1"/>
+          </a:lnRef>
+          <a:fillRef idx="0">
+            <a:schemeClr val="accent1"/>
+          </a:fillRef>
+          <a:effectRef idx="0">
+            <a:schemeClr val="accent1"/>
+          </a:effectRef>
+          <a:fontRef idx="minor">
+            <a:schemeClr val="tx1"/>
+          </a:fontRef>
+        </p:style>
+      </p:cxnSp>
+      <p:sp>
+        <p:nvSpPr>
+          <p:cNvPr id="72" name="Oval 71"/>
+          <p:cNvSpPr/>
+          <p:nvPr/>
+        </p:nvSpPr>
+        <p:spPr>
+          <a:xfrm>
+            <a:off x="4794615" y="1973271"/>
+            <a:ext cx="84568" cy="84568"/>
+          </a:xfrm>
+          <a:prstGeom prst="ellipse">
+            <a:avLst/>
+          </a:prstGeom>
+          <a:solidFill>
+            <a:srgbClr val="86D6C4"/>
+          </a:solidFill>
+          <a:ln>
+            <a:noFill/>
+          </a:ln>
+          <a:effectLst/>
+        </p:spPr>
+        <p:style>
+          <a:lnRef idx="1">
+            <a:schemeClr val="accent1"/>
+          </a:lnRef>
+          <a:fillRef idx="3">
+            <a:schemeClr val="accent1"/>
+          </a:fillRef>
+          <a:effectRef idx="0">
+            <a:schemeClr val="accent1"/>
+          </a:effectRef>
+          <a:fontRef idx="minor">
+            <a:schemeClr val="lt1"/>
+          </a:fontRef>
+        </p:style>
+        <p:txBody>
+          <a:bodyPr rtlCol="0" anchor="ctr"/>
+          <a:lstStyle/>
+          <a:p>
+            <a:pPr algn="ctr"/>
+          </a:p>
+        </p:txBody>
+      </p:sp>
+      <p:sp>
+        <p:nvSpPr>
+          <p:cNvPr id="73" name="カード_高校"/>
+          <p:cNvSpPr/>
+          <p:nvPr/>
+        </p:nvSpPr>
+        <p:spPr>
+          <a:xfrm>
+            <a:off x="451033" y="1416527"/>
+            <a:ext cx="3382751" cy="1198057"/>
+          </a:xfrm>
+          <a:prstGeom prst="roundRect">
+            <a:avLst>
+              <a:gd name="adj" fmla="val 13000"/>
+            </a:avLst>
+          </a:prstGeom>
+          <a:solidFill>
+            <a:srgbClr val="FFFFFF"/>
+          </a:solidFill>
+          <a:ln>
+            <a:noFill/>
+          </a:ln>
+          <a:effectLst>
+            <a:outerShdw blurRad="112758" dist="42284" dir="5400000" algn="t" rotWithShape="0">
+              <a:srgbClr val="2E9E8A">
+                <a:alpha val="16000"/>
+              </a:srgbClr>
+            </a:outerShdw>
+          </a:effectLst>
+        </p:spPr>
+        <p:style>
+          <a:lnRef idx="1">
+            <a:schemeClr val="accent1"/>
+          </a:lnRef>
+          <a:fillRef idx="3">
+            <a:schemeClr val="accent1"/>
+          </a:fillRef>
+          <a:effectRef idx="0">
+            <a:schemeClr val="accent1"/>
+          </a:effectRef>
+          <a:fontRef idx="minor">
+            <a:schemeClr val="lt1"/>
+          </a:fontRef>
+        </p:style>
+        <p:txBody>
+          <a:bodyPr rtlCol="0" anchor="ctr"/>
+          <a:lstStyle/>
+          <a:p>
+            <a:pPr algn="ctr"/>
+          </a:p>
+        </p:txBody>
+      </p:sp>
+      <p:sp>
+        <p:nvSpPr>
+          <p:cNvPr id="74" name="カード色バー"/>
+          <p:cNvSpPr/>
+          <p:nvPr/>
+        </p:nvSpPr>
+        <p:spPr>
+          <a:xfrm>
+            <a:off x="451033" y="1613854"/>
+            <a:ext cx="56379" cy="803403"/>
+          </a:xfrm>
+          <a:prstGeom prst="roundRect">
+            <a:avLst>
+              <a:gd name="adj" fmla="val 50000"/>
+            </a:avLst>
+          </a:prstGeom>
+          <a:solidFill>
+            <a:srgbClr val="86D6C4"/>
+          </a:solidFill>
+          <a:ln>
+            <a:noFill/>
+          </a:ln>
+          <a:effectLst/>
+        </p:spPr>
+        <p:style>
+          <a:lnRef idx="1">
+            <a:schemeClr val="accent1"/>
+          </a:lnRef>
+          <a:fillRef idx="3">
+            <a:schemeClr val="accent1"/>
+          </a:fillRef>
+          <a:effectRef idx="0">
+            <a:schemeClr val="accent1"/>
+          </a:effectRef>
+          <a:fontRef idx="minor">
+            <a:schemeClr val="lt1"/>
+          </a:fontRef>
+        </p:style>
+        <p:txBody>
+          <a:bodyPr rtlCol="0" anchor="ctr"/>
+          <a:lstStyle/>
+          <a:p>
+            <a:pPr algn="ctr"/>
+          </a:p>
+        </p:txBody>
+      </p:sp>
+      <p:sp>
+        <p:nvSpPr>
+          <p:cNvPr id="75" name="名称_高校"/>
+          <p:cNvSpPr txBox="1"/>
+          <p:nvPr/>
+        </p:nvSpPr>
+        <p:spPr>
+          <a:xfrm>
+            <a:off x="704739" y="1585664"/>
+            <a:ext cx="2959907" cy="197327"/>
+          </a:xfrm>
+          <a:prstGeom prst="rect">
+            <a:avLst/>
+          </a:prstGeom>
+          <a:noFill/>
+        </p:spPr>
+        <p:txBody>
+          <a:bodyPr wrap="square" lIns="0" rIns="0" tIns="0" bIns="0" anchor="t">
+            <a:spAutoFit/>
+          </a:bodyPr>
+          <a:lstStyle/>
+          <a:p>
+            <a:pPr algn="l"/>
+            <a:r>
+              <a:rPr sz="1165" b="1" spc="100">
+                <a:solidFill>
+                  <a:srgbClr val="5B6B73"/>
+                </a:solidFill>
+                <a:latin typeface="游ゴシック"/>
+                <a:ea typeface="游ゴシック"/>
+                <a:cs typeface="游ゴシック"/>
+              </a:rPr>
+              <a:t>高校</a:t>
+            </a:r>
+          </a:p>
+        </p:txBody>
+      </p:sp>
+      <p:sp>
+        <p:nvSpPr>
+          <p:cNvPr id="76" name="要点_高校"/>
+          <p:cNvSpPr txBox="1"/>
+          <p:nvPr/>
+        </p:nvSpPr>
+        <p:spPr>
+          <a:xfrm>
+            <a:off x="704739" y="1782991"/>
+            <a:ext cx="3030381" cy="295990"/>
+          </a:xfrm>
+          <a:prstGeom prst="rect">
+            <a:avLst/>
+          </a:prstGeom>
+          <a:noFill/>
+        </p:spPr>
+        <p:txBody>
+          <a:bodyPr wrap="square" lIns="0" rIns="0" tIns="0" bIns="0" anchor="t">
+            <a:spAutoFit/>
+          </a:bodyPr>
+          <a:lstStyle/>
+          <a:p>
+            <a:pPr algn="l"/>
+            <a:r>
+              <a:rPr sz="1609" b="1">
+                <a:solidFill>
+                  <a:srgbClr val="1F7D6C"/>
+                </a:solidFill>
+                <a:latin typeface="游ゴシック"/>
+                <a:ea typeface="游ゴシック"/>
+                <a:cs typeface="游ゴシック"/>
+              </a:rPr>
+              <a:t>探究と進路に生きる実績</a:t>
+            </a:r>
+          </a:p>
+        </p:txBody>
+      </p:sp>
+      <p:sp>
+        <p:nvSpPr>
+          <p:cNvPr id="77" name="説明_高校"/>
+          <p:cNvSpPr txBox="1"/>
+          <p:nvPr/>
+        </p:nvSpPr>
+        <p:spPr>
+          <a:xfrm>
+            <a:off x="704739" y="2121267"/>
+            <a:ext cx="3030381" cy="422843"/>
+          </a:xfrm>
+          <a:prstGeom prst="rect">
+            <a:avLst/>
+          </a:prstGeom>
+          <a:noFill/>
+        </p:spPr>
+        <p:txBody>
+          <a:bodyPr wrap="square" lIns="0" rIns="0" tIns="0" bIns="0" anchor="t">
+            <a:spAutoFit/>
+          </a:bodyPr>
+          <a:lstStyle/>
+          <a:p>
+            <a:pPr algn="l">
+              <a:lnSpc>
+                <a:spcPct val="115000"/>
+              </a:lnSpc>
+            </a:pPr>
+            <a:r>
+              <a:rPr sz="1054" b="0">
+                <a:solidFill>
+                  <a:srgbClr val="26323A"/>
+                </a:solidFill>
+                <a:latin typeface="游ゴシック"/>
+                <a:ea typeface="游ゴシック"/>
+                <a:cs typeface="游ゴシック"/>
+              </a:rPr>
+              <a:t>単位つきで受け入れやすく、探究テーマ</a:t>
+            </a:r>
+          </a:p>
+          <a:p>
+            <a:pPr algn="l">
+              <a:lnSpc>
+                <a:spcPct val="115000"/>
+              </a:lnSpc>
+            </a:pPr>
+            <a:r>
+              <a:rPr sz="1054" b="0">
+                <a:solidFill>
+                  <a:srgbClr val="26323A"/>
+                </a:solidFill>
+                <a:latin typeface="游ゴシック"/>
+                <a:ea typeface="游ゴシック"/>
+                <a:cs typeface="游ゴシック"/>
+              </a:rPr>
+              <a:t>探しと面接で語れる実績になります。</a:t>
+            </a:r>
+          </a:p>
+        </p:txBody>
+      </p:sp>
+      <p:sp>
+        <p:nvSpPr>
+          <p:cNvPr id="78" name="キャッチコピー"/>
+          <p:cNvSpPr txBox="1"/>
+          <p:nvPr/>
+        </p:nvSpPr>
+        <p:spPr>
+          <a:xfrm>
+            <a:off x="1162820" y="5976194"/>
+            <a:ext cx="9866358" cy="394654"/>
+          </a:xfrm>
+          <a:prstGeom prst="rect">
+            <a:avLst/>
+          </a:prstGeom>
+          <a:noFill/>
+        </p:spPr>
+        <p:txBody>
+          <a:bodyPr wrap="square" lIns="0" rIns="0" tIns="0" bIns="0" anchor="ctr">
+            <a:spAutoFit/>
+          </a:bodyPr>
+          <a:lstStyle/>
+          <a:p>
+            <a:pPr algn="ctr"/>
+            <a:r>
+              <a:rPr sz="1775" b="1">
+                <a:solidFill>
+                  <a:srgbClr val="26323A"/>
+                </a:solidFill>
+                <a:latin typeface="游ゴシック"/>
+                <a:ea typeface="游ゴシック"/>
+                <a:cs typeface="游ゴシック"/>
+              </a:rPr>
+              <a:t>学ぶ人も、迎える人も、地域も。みんなが共に育つ</a:t>
+            </a:r>
+          </a:p>
+        </p:txBody>
+      </p:sp>
+      <p:sp>
+        <p:nvSpPr>
+          <p:cNvPr id="79" name="下線"/>
+          <p:cNvSpPr/>
+          <p:nvPr/>
+        </p:nvSpPr>
+        <p:spPr>
+          <a:xfrm>
+            <a:off x="3100855" y="6399038"/>
+            <a:ext cx="5990289" cy="28189"/>
+          </a:xfrm>
+          <a:prstGeom prst="roundRect">
+            <a:avLst>
+              <a:gd name="adj" fmla="val 50000"/>
+            </a:avLst>
+          </a:prstGeom>
+          <a:solidFill>
+            <a:srgbClr val="F28C3C"/>
+          </a:solidFill>
+          <a:ln>
+            <a:noFill/>
+          </a:ln>
+          <a:effectLst/>
+        </p:spPr>
+        <p:style>
+          <a:lnRef idx="1">
+            <a:schemeClr val="accent1"/>
+          </a:lnRef>
+          <a:fillRef idx="3">
+            <a:schemeClr val="accent1"/>
+          </a:fillRef>
+          <a:effectRef idx="0">
+            <a:schemeClr val="accent1"/>
+          </a:effectRef>
+          <a:fontRef idx="minor">
+            <a:schemeClr val="lt1"/>
+          </a:fontRef>
+        </p:style>
+        <p:txBody>
+          <a:bodyPr rtlCol="0" anchor="ctr"/>
+          <a:lstStyle/>
+          <a:p>
+            <a:pPr algn="ctr"/>
+          </a:p>
+        </p:txBody>
+      </p:sp>
     </p:spTree>
   </p:cSld>
   <p:clrMapOvr>

</xml_diff>

<commit_message>
Simplify deck design: white background, flat cards, no shadows or header wave
Co-Authored-By: Claude Sonnet 5.5 <noreply@anthropic.com>
Claude-Session: https://claude.ai/code/session_01MxdMxhi7qZAPC9aBAhtpWC
</commit_message>
<xml_diff>
--- a/kyoiku-jisshu/共育実習_共創モデル.pptx
+++ b/kyoiku-jisshu/共育実習_共創モデル.pptx
@@ -4431,13 +4431,7 @@
           <a:ln>
             <a:noFill/>
           </a:ln>
-          <a:effectLst>
-            <a:outerShdw blurRad="112758" dist="42284" dir="5400000" algn="t" rotWithShape="0">
-              <a:srgbClr val="2E9E8A">
-                <a:alpha val="16000"/>
-              </a:srgbClr>
-            </a:outerShdw>
-          </a:effectLst>
+          <a:effectLst/>
         </p:spPr>
         <p:style>
           <a:lnRef idx="1">
@@ -5910,13 +5904,7 @@
           <a:ln>
             <a:noFill/>
           </a:ln>
-          <a:effectLst>
-            <a:outerShdw blurRad="112758" dist="42284" dir="5400000" algn="t" rotWithShape="0">
-              <a:srgbClr val="2E9E8A">
-                <a:alpha val="16000"/>
-              </a:srgbClr>
-            </a:outerShdw>
-          </a:effectLst>
+          <a:effectLst/>
         </p:spPr>
         <p:style>
           <a:lnRef idx="1">
@@ -6220,13 +6208,7 @@
           <a:ln>
             <a:noFill/>
           </a:ln>
-          <a:effectLst>
-            <a:outerShdw blurRad="112758" dist="42284" dir="5400000" algn="t" rotWithShape="0">
-              <a:srgbClr val="2E9E8A">
-                <a:alpha val="16000"/>
-              </a:srgbClr>
-            </a:outerShdw>
-          </a:effectLst>
+          <a:effectLst/>
         </p:spPr>
         <p:style>
           <a:lnRef idx="1">
@@ -6530,13 +6512,7 @@
           <a:ln>
             <a:noFill/>
           </a:ln>
-          <a:effectLst>
-            <a:outerShdw blurRad="112758" dist="42284" dir="5400000" algn="t" rotWithShape="0">
-              <a:srgbClr val="2E9E8A">
-                <a:alpha val="16000"/>
-              </a:srgbClr>
-            </a:outerShdw>
-          </a:effectLst>
+          <a:effectLst/>
         </p:spPr>
         <p:style>
           <a:lnRef idx="1">
@@ -6840,13 +6816,7 @@
           <a:ln>
             <a:noFill/>
           </a:ln>
-          <a:effectLst>
-            <a:outerShdw blurRad="112758" dist="42284" dir="5400000" algn="t" rotWithShape="0">
-              <a:srgbClr val="2E9E8A">
-                <a:alpha val="16000"/>
-              </a:srgbClr>
-            </a:outerShdw>
-          </a:effectLst>
+          <a:effectLst/>
         </p:spPr>
         <p:style>
           <a:lnRef idx="1">
@@ -7150,13 +7120,7 @@
           <a:ln>
             <a:noFill/>
           </a:ln>
-          <a:effectLst>
-            <a:outerShdw blurRad="112758" dist="42284" dir="5400000" algn="t" rotWithShape="0">
-              <a:srgbClr val="2E9E8A">
-                <a:alpha val="16000"/>
-              </a:srgbClr>
-            </a:outerShdw>
-          </a:effectLst>
+          <a:effectLst/>
         </p:spPr>
         <p:style>
           <a:lnRef idx="1">
@@ -7460,13 +7424,7 @@
           <a:ln>
             <a:noFill/>
           </a:ln>
-          <a:effectLst>
-            <a:outerShdw blurRad="112758" dist="42284" dir="5400000" algn="t" rotWithShape="0">
-              <a:srgbClr val="2E9E8A">
-                <a:alpha val="16000"/>
-              </a:srgbClr>
-            </a:outerShdw>
-          </a:effectLst>
+          <a:effectLst/>
         </p:spPr>
         <p:style>
           <a:lnRef idx="1">

</xml_diff>